<commit_message>
cleanning no needed and duplicated info
</commit_message>
<xml_diff>
--- a/Poster Presentation Template.pptx
+++ b/Poster Presentation Template.pptx
@@ -197,7 +197,7 @@
 <file path=ppt/revisionInfo.xml><?xml version="1.0" encoding="utf-8"?>
 <p1510:revInfo xmlns:a="http://schemas.openxmlformats.org/drawingml/2006/main" xmlns:r="http://schemas.openxmlformats.org/officeDocument/2006/relationships" xmlns:p1510="http://schemas.microsoft.com/office/powerpoint/2015/10/main">
   <p1510:revLst>
-    <p1510:client id="{7D35C6E7-5499-42E0-B8E1-E892D250CE58}" v="26" dt="2026-05-31T22:15:08.306"/>
+    <p1510:client id="{7D35C6E7-5499-42E0-B8E1-E892D250CE58}" v="68" dt="2026-05-31T22:43:14.865"/>
   </p1510:revLst>
 </p1510:revInfo>
 </file>
@@ -207,12 +207,12 @@
   <pc:docChgLst>
     <pc:chgData name="Laura Lujan" userId="da8756df24445728" providerId="LiveId" clId="{A86C11ED-B9B4-4AE9-9A57-E5E63AAEA8AA}"/>
     <pc:docChg chg="undo custSel modSld">
-      <pc:chgData name="Laura Lujan" userId="da8756df24445728" providerId="LiveId" clId="{A86C11ED-B9B4-4AE9-9A57-E5E63AAEA8AA}" dt="2026-05-31T22:15:29.301" v="274" actId="313"/>
+      <pc:chgData name="Laura Lujan" userId="da8756df24445728" providerId="LiveId" clId="{A86C11ED-B9B4-4AE9-9A57-E5E63AAEA8AA}" dt="2026-05-31T22:46:19.070" v="603" actId="20577"/>
       <pc:docMkLst>
         <pc:docMk/>
       </pc:docMkLst>
       <pc:sldChg chg="addSp delSp modSp mod">
-        <pc:chgData name="Laura Lujan" userId="da8756df24445728" providerId="LiveId" clId="{A86C11ED-B9B4-4AE9-9A57-E5E63AAEA8AA}" dt="2026-05-31T22:15:29.301" v="274" actId="313"/>
+        <pc:chgData name="Laura Lujan" userId="da8756df24445728" providerId="LiveId" clId="{A86C11ED-B9B4-4AE9-9A57-E5E63AAEA8AA}" dt="2026-05-31T22:46:19.070" v="603" actId="20577"/>
         <pc:sldMkLst>
           <pc:docMk/>
           <pc:sldMk cId="3160527046" sldId="258"/>
@@ -231,6 +231,14 @@
             <pc:docMk/>
             <pc:sldMk cId="3160527046" sldId="258"/>
             <ac:spMk id="5" creationId="{00000000-0000-0000-0000-000000000000}"/>
+          </ac:spMkLst>
+        </pc:spChg>
+        <pc:spChg chg="mod">
+          <ac:chgData name="Laura Lujan" userId="da8756df24445728" providerId="LiveId" clId="{A86C11ED-B9B4-4AE9-9A57-E5E63AAEA8AA}" dt="2026-05-31T22:38:37.334" v="362" actId="1076"/>
+          <ac:spMkLst>
+            <pc:docMk/>
+            <pc:sldMk cId="3160527046" sldId="258"/>
+            <ac:spMk id="9" creationId="{00000000-0000-0000-0000-000000000000}"/>
           </ac:spMkLst>
         </pc:spChg>
         <pc:spChg chg="add">
@@ -266,7 +274,7 @@
           </ac:spMkLst>
         </pc:spChg>
         <pc:spChg chg="mod">
-          <ac:chgData name="Laura Lujan" userId="da8756df24445728" providerId="LiveId" clId="{A86C11ED-B9B4-4AE9-9A57-E5E63AAEA8AA}" dt="2026-05-31T21:37:56.183" v="6" actId="20577"/>
+          <ac:chgData name="Laura Lujan" userId="da8756df24445728" providerId="LiveId" clId="{A86C11ED-B9B4-4AE9-9A57-E5E63AAEA8AA}" dt="2026-05-31T22:46:19.070" v="603" actId="20577"/>
           <ac:spMkLst>
             <pc:docMk/>
             <pc:sldMk cId="3160527046" sldId="258"/>
@@ -322,6 +330,46 @@
           </ac:spMkLst>
         </pc:spChg>
         <pc:spChg chg="mod">
+          <ac:chgData name="Laura Lujan" userId="da8756df24445728" providerId="LiveId" clId="{A86C11ED-B9B4-4AE9-9A57-E5E63AAEA8AA}" dt="2026-05-31T22:44:10.527" v="410" actId="1076"/>
+          <ac:spMkLst>
+            <pc:docMk/>
+            <pc:sldMk cId="3160527046" sldId="258"/>
+            <ac:spMk id="27" creationId="{00000000-0000-0000-0000-000000000000}"/>
+          </ac:spMkLst>
+        </pc:spChg>
+        <pc:spChg chg="mod">
+          <ac:chgData name="Laura Lujan" userId="da8756df24445728" providerId="LiveId" clId="{A86C11ED-B9B4-4AE9-9A57-E5E63AAEA8AA}" dt="2026-05-31T22:41:04.603" v="389" actId="1076"/>
+          <ac:spMkLst>
+            <pc:docMk/>
+            <pc:sldMk cId="3160527046" sldId="258"/>
+            <ac:spMk id="28" creationId="{00000000-0000-0000-0000-000000000000}"/>
+          </ac:spMkLst>
+        </pc:spChg>
+        <pc:spChg chg="del">
+          <ac:chgData name="Laura Lujan" userId="da8756df24445728" providerId="LiveId" clId="{A86C11ED-B9B4-4AE9-9A57-E5E63AAEA8AA}" dt="2026-05-31T22:32:20.349" v="314" actId="478"/>
+          <ac:spMkLst>
+            <pc:docMk/>
+            <pc:sldMk cId="3160527046" sldId="258"/>
+            <ac:spMk id="29" creationId="{00000000-0000-0000-0000-000000000000}"/>
+          </ac:spMkLst>
+        </pc:spChg>
+        <pc:spChg chg="mod">
+          <ac:chgData name="Laura Lujan" userId="da8756df24445728" providerId="LiveId" clId="{A86C11ED-B9B4-4AE9-9A57-E5E63AAEA8AA}" dt="2026-05-31T22:38:27.765" v="358" actId="1076"/>
+          <ac:spMkLst>
+            <pc:docMk/>
+            <pc:sldMk cId="3160527046" sldId="258"/>
+            <ac:spMk id="30" creationId="{00000000-0000-0000-0000-000000000000}"/>
+          </ac:spMkLst>
+        </pc:spChg>
+        <pc:spChg chg="mod">
+          <ac:chgData name="Laura Lujan" userId="da8756df24445728" providerId="LiveId" clId="{A86C11ED-B9B4-4AE9-9A57-E5E63AAEA8AA}" dt="2026-05-31T22:38:30.848" v="359" actId="1076"/>
+          <ac:spMkLst>
+            <pc:docMk/>
+            <pc:sldMk cId="3160527046" sldId="258"/>
+            <ac:spMk id="31" creationId="{00000000-0000-0000-0000-000000000000}"/>
+          </ac:spMkLst>
+        </pc:spChg>
+        <pc:spChg chg="mod">
           <ac:chgData name="Laura Lujan" userId="da8756df24445728" providerId="LiveId" clId="{A86C11ED-B9B4-4AE9-9A57-E5E63AAEA8AA}" dt="2026-05-31T21:45:16.721" v="223" actId="108"/>
           <ac:spMkLst>
             <pc:docMk/>
@@ -354,6 +402,22 @@
           </ac:spMkLst>
         </pc:spChg>
         <pc:spChg chg="mod">
+          <ac:chgData name="Laura Lujan" userId="da8756df24445728" providerId="LiveId" clId="{A86C11ED-B9B4-4AE9-9A57-E5E63AAEA8AA}" dt="2026-05-31T22:41:07.041" v="390" actId="1076"/>
+          <ac:spMkLst>
+            <pc:docMk/>
+            <pc:sldMk cId="3160527046" sldId="258"/>
+            <ac:spMk id="36" creationId="{00000000-0000-0000-0000-000000000000}"/>
+          </ac:spMkLst>
+        </pc:spChg>
+        <pc:spChg chg="del">
+          <ac:chgData name="Laura Lujan" userId="da8756df24445728" providerId="LiveId" clId="{A86C11ED-B9B4-4AE9-9A57-E5E63AAEA8AA}" dt="2026-05-31T22:32:18.194" v="313" actId="478"/>
+          <ac:spMkLst>
+            <pc:docMk/>
+            <pc:sldMk cId="3160527046" sldId="258"/>
+            <ac:spMk id="38" creationId="{00000000-0000-0000-0000-000000000000}"/>
+          </ac:spMkLst>
+        </pc:spChg>
+        <pc:spChg chg="mod">
           <ac:chgData name="Laura Lujan" userId="da8756df24445728" providerId="LiveId" clId="{A86C11ED-B9B4-4AE9-9A57-E5E63AAEA8AA}" dt="2026-05-31T21:50:23.243" v="247" actId="1076"/>
           <ac:spMkLst>
             <pc:docMk/>
@@ -369,12 +433,36 @@
             <ac:spMk id="41" creationId="{00000000-0000-0000-0000-000000000000}"/>
           </ac:spMkLst>
         </pc:spChg>
+        <pc:spChg chg="mod">
+          <ac:chgData name="Laura Lujan" userId="da8756df24445728" providerId="LiveId" clId="{A86C11ED-B9B4-4AE9-9A57-E5E63AAEA8AA}" dt="2026-05-31T22:40:19.078" v="383" actId="313"/>
+          <ac:spMkLst>
+            <pc:docMk/>
+            <pc:sldMk cId="3160527046" sldId="258"/>
+            <ac:spMk id="42" creationId="{00000000-0000-0000-0000-000000000000}"/>
+          </ac:spMkLst>
+        </pc:spChg>
         <pc:spChg chg="add">
           <ac:chgData name="Laura Lujan" userId="da8756df24445728" providerId="LiveId" clId="{A86C11ED-B9B4-4AE9-9A57-E5E63AAEA8AA}" dt="2026-05-31T21:42:33.656" v="88"/>
           <ac:spMkLst>
             <pc:docMk/>
             <pc:sldMk cId="3160527046" sldId="258"/>
             <ac:spMk id="44" creationId="{6C3F2AFC-CEA4-6C84-79F8-56F75DA24964}"/>
+          </ac:spMkLst>
+        </pc:spChg>
+        <pc:spChg chg="mod">
+          <ac:chgData name="Laura Lujan" userId="da8756df24445728" providerId="LiveId" clId="{A86C11ED-B9B4-4AE9-9A57-E5E63AAEA8AA}" dt="2026-05-31T22:44:14.763" v="411" actId="1076"/>
+          <ac:spMkLst>
+            <pc:docMk/>
+            <pc:sldMk cId="3160527046" sldId="258"/>
+            <ac:spMk id="46" creationId="{BA7BC14E-5C68-4BFC-B8B8-A1CD9BF3BFC9}"/>
+          </ac:spMkLst>
+        </pc:spChg>
+        <pc:spChg chg="mod">
+          <ac:chgData name="Laura Lujan" userId="da8756df24445728" providerId="LiveId" clId="{A86C11ED-B9B4-4AE9-9A57-E5E63AAEA8AA}" dt="2026-05-31T22:35:28.619" v="343" actId="14100"/>
+          <ac:spMkLst>
+            <pc:docMk/>
+            <pc:sldMk cId="3160527046" sldId="258"/>
+            <ac:spMk id="47" creationId="{C12A8FE5-E10F-498E-9E7D-EC629905A877}"/>
           </ac:spMkLst>
         </pc:spChg>
         <pc:spChg chg="add">
@@ -433,12 +521,76 @@
             <ac:spMk id="57" creationId="{BBC13E77-F5BD-1782-A263-8CA3A465656D}"/>
           </ac:spMkLst>
         </pc:spChg>
+        <pc:spChg chg="add del mod">
+          <ac:chgData name="Laura Lujan" userId="da8756df24445728" providerId="LiveId" clId="{A86C11ED-B9B4-4AE9-9A57-E5E63AAEA8AA}" dt="2026-05-31T22:34:36.842" v="333" actId="478"/>
+          <ac:spMkLst>
+            <pc:docMk/>
+            <pc:sldMk cId="3160527046" sldId="258"/>
+            <ac:spMk id="4101" creationId="{313E4995-864B-8565-A858-76D91CFF22FF}"/>
+          </ac:spMkLst>
+        </pc:spChg>
+        <pc:spChg chg="add del mod">
+          <ac:chgData name="Laura Lujan" userId="da8756df24445728" providerId="LiveId" clId="{A86C11ED-B9B4-4AE9-9A57-E5E63AAEA8AA}" dt="2026-05-31T22:32:50.176" v="320" actId="478"/>
+          <ac:spMkLst>
+            <pc:docMk/>
+            <pc:sldMk cId="3160527046" sldId="258"/>
+            <ac:spMk id="4103" creationId="{F02FB0B0-3038-4028-E268-45A0A43AC6C6}"/>
+          </ac:spMkLst>
+        </pc:spChg>
+        <pc:spChg chg="add mod">
+          <ac:chgData name="Laura Lujan" userId="da8756df24445728" providerId="LiveId" clId="{A86C11ED-B9B4-4AE9-9A57-E5E63AAEA8AA}" dt="2026-05-31T22:37:06.026" v="348"/>
+          <ac:spMkLst>
+            <pc:docMk/>
+            <pc:sldMk cId="3160527046" sldId="258"/>
+            <ac:spMk id="4106" creationId="{5EE93C39-D4B7-3D45-5E36-D3EB6767D705}"/>
+          </ac:spMkLst>
+        </pc:spChg>
+        <pc:spChg chg="add mod">
+          <ac:chgData name="Laura Lujan" userId="da8756df24445728" providerId="LiveId" clId="{A86C11ED-B9B4-4AE9-9A57-E5E63AAEA8AA}" dt="2026-05-31T22:37:27.560" v="354" actId="1076"/>
+          <ac:spMkLst>
+            <pc:docMk/>
+            <pc:sldMk cId="3160527046" sldId="258"/>
+            <ac:spMk id="4107" creationId="{AECE974E-F71E-E5F4-5572-8595BC039CC1}"/>
+          </ac:spMkLst>
+        </pc:spChg>
+        <pc:spChg chg="add mod">
+          <ac:chgData name="Laura Lujan" userId="da8756df24445728" providerId="LiveId" clId="{A86C11ED-B9B4-4AE9-9A57-E5E63AAEA8AA}" dt="2026-05-31T22:44:25.804" v="413" actId="1076"/>
+          <ac:spMkLst>
+            <pc:docMk/>
+            <pc:sldMk cId="3160527046" sldId="258"/>
+            <ac:spMk id="4108" creationId="{C836E6B4-8276-34A9-F8FE-C29ADDB1E038}"/>
+          </ac:spMkLst>
+        </pc:spChg>
+        <pc:spChg chg="add mod">
+          <ac:chgData name="Laura Lujan" userId="da8756df24445728" providerId="LiveId" clId="{A86C11ED-B9B4-4AE9-9A57-E5E63AAEA8AA}" dt="2026-05-31T22:44:28.705" v="414" actId="1076"/>
+          <ac:spMkLst>
+            <pc:docMk/>
+            <pc:sldMk cId="3160527046" sldId="258"/>
+            <ac:spMk id="4109" creationId="{B81B1A0F-25E9-6928-FCCE-A9A259874501}"/>
+          </ac:spMkLst>
+        </pc:spChg>
+        <pc:graphicFrameChg chg="del">
+          <ac:chgData name="Laura Lujan" userId="da8756df24445728" providerId="LiveId" clId="{A86C11ED-B9B4-4AE9-9A57-E5E63AAEA8AA}" dt="2026-05-31T22:25:18.995" v="275" actId="478"/>
+          <ac:graphicFrameMkLst>
+            <pc:docMk/>
+            <pc:sldMk cId="3160527046" sldId="258"/>
+            <ac:graphicFrameMk id="37" creationId="{00000000-0000-0000-0000-000000000000}"/>
+          </ac:graphicFrameMkLst>
+        </pc:graphicFrameChg>
         <pc:picChg chg="add mod">
           <ac:chgData name="Laura Lujan" userId="da8756df24445728" providerId="LiveId" clId="{A86C11ED-B9B4-4AE9-9A57-E5E63AAEA8AA}" dt="2026-05-31T21:44:31.086" v="213" actId="1076"/>
           <ac:picMkLst>
             <pc:docMk/>
             <pc:sldMk cId="3160527046" sldId="258"/>
             <ac:picMk id="10" creationId="{836E3AC5-9837-1983-DB05-8282D74C4D2B}"/>
+          </ac:picMkLst>
+        </pc:picChg>
+        <pc:picChg chg="del">
+          <ac:chgData name="Laura Lujan" userId="da8756df24445728" providerId="LiveId" clId="{A86C11ED-B9B4-4AE9-9A57-E5E63AAEA8AA}" dt="2026-05-31T22:34:31.511" v="331" actId="478"/>
+          <ac:picMkLst>
+            <pc:docMk/>
+            <pc:sldMk cId="3160527046" sldId="258"/>
+            <ac:picMk id="19" creationId="{00000000-0000-0000-0000-000000000000}"/>
           </ac:picMkLst>
         </pc:picChg>
         <pc:picChg chg="del">
@@ -473,12 +625,68 @@
             <ac:picMk id="61" creationId="{DA1A3584-44A0-C568-485A-BB9D487A8BD1}"/>
           </ac:picMkLst>
         </pc:picChg>
+        <pc:picChg chg="add mod">
+          <ac:chgData name="Laura Lujan" userId="da8756df24445728" providerId="LiveId" clId="{A86C11ED-B9B4-4AE9-9A57-E5E63AAEA8AA}" dt="2026-05-31T22:25:37.983" v="282" actId="14100"/>
+          <ac:picMkLst>
+            <pc:docMk/>
+            <pc:sldMk cId="3160527046" sldId="258"/>
+            <ac:picMk id="63" creationId="{9B91F188-A1D1-4CD8-7891-C98C11932D18}"/>
+          </ac:picMkLst>
+        </pc:picChg>
+        <pc:picChg chg="add mod">
+          <ac:chgData name="Laura Lujan" userId="da8756df24445728" providerId="LiveId" clId="{A86C11ED-B9B4-4AE9-9A57-E5E63AAEA8AA}" dt="2026-05-31T22:44:05.689" v="409" actId="14100"/>
+          <ac:picMkLst>
+            <pc:docMk/>
+            <pc:sldMk cId="3160527046" sldId="258"/>
+            <ac:picMk id="4096" creationId="{6A95C329-D2AC-9133-C0C1-DD740C493269}"/>
+          </ac:picMkLst>
+        </pc:picChg>
+        <pc:picChg chg="del">
+          <ac:chgData name="Laura Lujan" userId="da8756df24445728" providerId="LiveId" clId="{A86C11ED-B9B4-4AE9-9A57-E5E63AAEA8AA}" dt="2026-05-31T22:34:32.275" v="332" actId="478"/>
+          <ac:picMkLst>
+            <pc:docMk/>
+            <pc:sldMk cId="3160527046" sldId="258"/>
+            <ac:picMk id="4098" creationId="{00000000-0000-0000-0000-000000000000}"/>
+          </ac:picMkLst>
+        </pc:picChg>
         <pc:picChg chg="del">
           <ac:chgData name="Laura Lujan" userId="da8756df24445728" providerId="LiveId" clId="{A86C11ED-B9B4-4AE9-9A57-E5E63AAEA8AA}" dt="2026-05-31T21:40:37.733" v="18" actId="478"/>
           <ac:picMkLst>
             <pc:docMk/>
             <pc:sldMk cId="3160527046" sldId="258"/>
             <ac:picMk id="4099" creationId="{00000000-0000-0000-0000-000000000000}"/>
+          </ac:picMkLst>
+        </pc:picChg>
+        <pc:picChg chg="del">
+          <ac:chgData name="Laura Lujan" userId="da8756df24445728" providerId="LiveId" clId="{A86C11ED-B9B4-4AE9-9A57-E5E63AAEA8AA}" dt="2026-05-31T22:29:24.888" v="297" actId="478"/>
+          <ac:picMkLst>
+            <pc:docMk/>
+            <pc:sldMk cId="3160527046" sldId="258"/>
+            <ac:picMk id="4100" creationId="{00000000-0000-0000-0000-000000000000}"/>
+          </ac:picMkLst>
+        </pc:picChg>
+        <pc:picChg chg="add mod">
+          <ac:chgData name="Laura Lujan" userId="da8756df24445728" providerId="LiveId" clId="{A86C11ED-B9B4-4AE9-9A57-E5E63AAEA8AA}" dt="2026-05-31T22:44:21.222" v="412" actId="1076"/>
+          <ac:picMkLst>
+            <pc:docMk/>
+            <pc:sldMk cId="3160527046" sldId="258"/>
+            <ac:picMk id="4104" creationId="{AB271B9C-A9E4-6060-D7D1-0B357D9BFAB6}"/>
+          </ac:picMkLst>
+        </pc:picChg>
+        <pc:picChg chg="add mod">
+          <ac:chgData name="Laura Lujan" userId="da8756df24445728" providerId="LiveId" clId="{A86C11ED-B9B4-4AE9-9A57-E5E63AAEA8AA}" dt="2026-05-31T22:38:33.432" v="361" actId="1076"/>
+          <ac:picMkLst>
+            <pc:docMk/>
+            <pc:sldMk cId="3160527046" sldId="258"/>
+            <ac:picMk id="4105" creationId="{0DC3B3CF-D257-23EA-B1A7-A61773876D1A}"/>
+          </ac:picMkLst>
+        </pc:picChg>
+        <pc:picChg chg="add mod">
+          <ac:chgData name="Laura Lujan" userId="da8756df24445728" providerId="LiveId" clId="{A86C11ED-B9B4-4AE9-9A57-E5E63AAEA8AA}" dt="2026-05-31T22:44:36.477" v="418" actId="1076"/>
+          <ac:picMkLst>
+            <pc:docMk/>
+            <pc:sldMk cId="3160527046" sldId="258"/>
+            <ac:picMk id="4110" creationId="{30FEB3F4-83BF-7EA1-0BDB-E98AB862EDD0}"/>
           </ac:picMkLst>
         </pc:picChg>
       </pc:sldChg>
@@ -14670,7 +14878,7 @@
         </p:nvSpPr>
         <p:spPr>
           <a:xfrm>
-            <a:off x="33346443" y="21931197"/>
+            <a:off x="33397599" y="18770373"/>
             <a:ext cx="10047018" cy="677100"/>
           </a:xfrm>
         </p:spPr>
@@ -14746,7 +14954,21 @@
                 <a:latin typeface="Arial" panose="020B0604020202020204" pitchFamily="34" charset="0"/>
                 <a:cs typeface="Arial" panose="020B0604020202020204" pitchFamily="34" charset="0"/>
               </a:rPr>
-              <a:t>Graham Glanville, CCT College Dublin / University of Hertfordshire (EdD Cohort 9), May 2019</a:t>
+              <a:t>Laura Elena Lujan Martinez, CCT College, Student No. 2021418, Supervisor: </a:t>
+            </a:r>
+            <a:r>
+              <a:rPr lang="en-US" sz="4800" b="1" dirty="0" err="1">
+                <a:latin typeface="Arial" panose="020B0604020202020204" pitchFamily="34" charset="0"/>
+                <a:cs typeface="Arial" panose="020B0604020202020204" pitchFamily="34" charset="0"/>
+              </a:rPr>
+              <a:t>Muhamaad</a:t>
+            </a:r>
+            <a:r>
+              <a:rPr lang="en-US" sz="4800" b="1" dirty="0">
+                <a:latin typeface="Arial" panose="020B0604020202020204" pitchFamily="34" charset="0"/>
+                <a:cs typeface="Arial" panose="020B0604020202020204" pitchFamily="34" charset="0"/>
+              </a:rPr>
+              <a:t> Iqbal, 2026</a:t>
             </a:r>
           </a:p>
         </p:txBody>
@@ -14783,168 +15005,6 @@
           </a:p>
         </p:txBody>
       </p:sp>
-      <p:pic>
-        <p:nvPicPr>
-          <p:cNvPr id="4098" name="Picture 2"/>
-          <p:cNvPicPr>
-            <a:picLocks noChangeAspect="1" noChangeArrowheads="1"/>
-          </p:cNvPicPr>
-          <p:nvPr/>
-        </p:nvPicPr>
-        <p:blipFill>
-          <a:blip r:embed="rId3">
-            <a:extLst>
-              <a:ext uri="{28A0092B-C50C-407E-A947-70E740481C1C}">
-                <a14:useLocalDpi xmlns:a14="http://schemas.microsoft.com/office/drawing/2010/main" val="0"/>
-              </a:ext>
-            </a:extLst>
-          </a:blip>
-          <a:srcRect/>
-          <a:stretch>
-            <a:fillRect/>
-          </a:stretch>
-        </p:blipFill>
-        <p:spPr bwMode="auto">
-          <a:xfrm>
-            <a:off x="33408415" y="10820362"/>
-            <a:ext cx="9841664" cy="5223653"/>
-          </a:xfrm>
-          <a:prstGeom prst="rect">
-            <a:avLst/>
-          </a:prstGeom>
-          <a:noFill/>
-          <a:ln>
-            <a:noFill/>
-          </a:ln>
-          <a:extLst>
-            <a:ext uri="{909E8E84-426E-40DD-AFC4-6F175D3DCCD1}">
-              <a14:hiddenFill xmlns:a14="http://schemas.microsoft.com/office/drawing/2010/main">
-                <a:solidFill>
-                  <a:schemeClr val="accent1"/>
-                </a:solidFill>
-              </a14:hiddenFill>
-            </a:ext>
-            <a:ext uri="{91240B29-F687-4F45-9708-019B960494DF}">
-              <a14:hiddenLine xmlns:a14="http://schemas.microsoft.com/office/drawing/2010/main" w="9525">
-                <a:solidFill>
-                  <a:schemeClr val="tx1"/>
-                </a:solidFill>
-                <a:miter lim="800000"/>
-                <a:headEnd/>
-                <a:tailEnd/>
-              </a14:hiddenLine>
-            </a:ext>
-          </a:extLst>
-        </p:spPr>
-      </p:pic>
-      <p:pic>
-        <p:nvPicPr>
-          <p:cNvPr id="19" name="Picture 3"/>
-          <p:cNvPicPr>
-            <a:picLocks noChangeAspect="1" noChangeArrowheads="1"/>
-          </p:cNvPicPr>
-          <p:nvPr/>
-        </p:nvPicPr>
-        <p:blipFill>
-          <a:blip r:embed="rId4">
-            <a:extLst>
-              <a:ext uri="{28A0092B-C50C-407E-A947-70E740481C1C}">
-                <a14:useLocalDpi xmlns:a14="http://schemas.microsoft.com/office/drawing/2010/main" val="0"/>
-              </a:ext>
-            </a:extLst>
-          </a:blip>
-          <a:srcRect/>
-          <a:stretch>
-            <a:fillRect/>
-          </a:stretch>
-        </p:blipFill>
-        <p:spPr bwMode="auto">
-          <a:xfrm>
-            <a:off x="33392567" y="16426199"/>
-            <a:ext cx="9857512" cy="5248213"/>
-          </a:xfrm>
-          <a:prstGeom prst="rect">
-            <a:avLst/>
-          </a:prstGeom>
-          <a:noFill/>
-          <a:ln>
-            <a:noFill/>
-          </a:ln>
-          <a:extLst>
-            <a:ext uri="{909E8E84-426E-40DD-AFC4-6F175D3DCCD1}">
-              <a14:hiddenFill xmlns:a14="http://schemas.microsoft.com/office/drawing/2010/main">
-                <a:solidFill>
-                  <a:schemeClr val="accent1"/>
-                </a:solidFill>
-              </a14:hiddenFill>
-            </a:ext>
-            <a:ext uri="{91240B29-F687-4F45-9708-019B960494DF}">
-              <a14:hiddenLine xmlns:a14="http://schemas.microsoft.com/office/drawing/2010/main" w="9525">
-                <a:solidFill>
-                  <a:schemeClr val="tx1"/>
-                </a:solidFill>
-                <a:miter lim="800000"/>
-                <a:headEnd/>
-                <a:tailEnd/>
-              </a14:hiddenLine>
-            </a:ext>
-          </a:extLst>
-        </p:spPr>
-      </p:pic>
-      <p:pic>
-        <p:nvPicPr>
-          <p:cNvPr id="4100" name="Picture 4"/>
-          <p:cNvPicPr>
-            <a:picLocks noChangeAspect="1" noChangeArrowheads="1"/>
-          </p:cNvPicPr>
-          <p:nvPr/>
-        </p:nvPicPr>
-        <p:blipFill>
-          <a:blip r:embed="rId5">
-            <a:extLst>
-              <a:ext uri="{28A0092B-C50C-407E-A947-70E740481C1C}">
-                <a14:useLocalDpi xmlns:a14="http://schemas.microsoft.com/office/drawing/2010/main" val="0"/>
-              </a:ext>
-            </a:extLst>
-          </a:blip>
-          <a:srcRect/>
-          <a:stretch>
-            <a:fillRect/>
-          </a:stretch>
-        </p:blipFill>
-        <p:spPr bwMode="auto">
-          <a:xfrm>
-            <a:off x="22401443" y="17642446"/>
-            <a:ext cx="9965607" cy="7063141"/>
-          </a:xfrm>
-          <a:prstGeom prst="rect">
-            <a:avLst/>
-          </a:prstGeom>
-          <a:noFill/>
-          <a:ln>
-            <a:noFill/>
-          </a:ln>
-          <a:extLst>
-            <a:ext uri="{909E8E84-426E-40DD-AFC4-6F175D3DCCD1}">
-              <a14:hiddenFill xmlns:a14="http://schemas.microsoft.com/office/drawing/2010/main">
-                <a:solidFill>
-                  <a:schemeClr val="accent1"/>
-                </a:solidFill>
-              </a14:hiddenFill>
-            </a:ext>
-            <a:ext uri="{91240B29-F687-4F45-9708-019B960494DF}">
-              <a14:hiddenLine xmlns:a14="http://schemas.microsoft.com/office/drawing/2010/main" w="9525">
-                <a:solidFill>
-                  <a:schemeClr val="tx1"/>
-                </a:solidFill>
-                <a:miter lim="800000"/>
-                <a:headEnd/>
-                <a:tailEnd/>
-              </a14:hiddenLine>
-            </a:ext>
-          </a:extLst>
-        </p:spPr>
-      </p:pic>
       <p:sp>
         <p:nvSpPr>
           <p:cNvPr id="27" name="Text Placeholder 6"/>
@@ -14957,7 +15017,7 @@
         </p:nvSpPr>
         <p:spPr>
           <a:xfrm>
-            <a:off x="22414720" y="11807392"/>
+            <a:off x="22508758" y="16623054"/>
             <a:ext cx="10048874" cy="846363"/>
           </a:xfrm>
         </p:spPr>
@@ -14970,7 +15030,7 @@
                 <a:latin typeface="Arial" panose="020B0604020202020204" pitchFamily="34" charset="0"/>
                 <a:cs typeface="Arial" panose="020B0604020202020204" pitchFamily="34" charset="0"/>
               </a:rPr>
-              <a:t>Student Engagement</a:t>
+              <a:t>Feature Importance</a:t>
             </a:r>
           </a:p>
         </p:txBody>
@@ -14987,7 +15047,7 @@
         </p:nvSpPr>
         <p:spPr>
           <a:xfrm>
-            <a:off x="22415504" y="6392906"/>
+            <a:off x="22342697" y="6211384"/>
             <a:ext cx="10048874" cy="846363"/>
           </a:xfrm>
         </p:spPr>
@@ -15000,37 +15060,7 @@
                 <a:latin typeface="Arial" panose="020B0604020202020204" pitchFamily="34" charset="0"/>
                 <a:cs typeface="Arial" panose="020B0604020202020204" pitchFamily="34" charset="0"/>
               </a:rPr>
-              <a:t>Reflective Learning</a:t>
-            </a:r>
-          </a:p>
-        </p:txBody>
-      </p:sp>
-      <p:sp>
-        <p:nvSpPr>
-          <p:cNvPr id="29" name="Text Placeholder 6"/>
-          <p:cNvSpPr>
-            <a:spLocks noGrp="1"/>
-          </p:cNvSpPr>
-          <p:nvPr>
-            <p:ph type="body" sz="quarter" idx="23"/>
-          </p:nvPr>
-        </p:nvSpPr>
-        <p:spPr>
-          <a:xfrm>
-            <a:off x="22401444" y="25388262"/>
-            <a:ext cx="10048874" cy="846363"/>
-          </a:xfrm>
-        </p:spPr>
-        <p:txBody>
-          <a:bodyPr/>
-          <a:lstStyle/>
-          <a:p>
-            <a:r>
-              <a:rPr lang="en-US" i="1" u="sng" dirty="0">
-                <a:latin typeface="Arial" panose="020B0604020202020204" pitchFamily="34" charset="0"/>
-                <a:cs typeface="Arial" panose="020B0604020202020204" pitchFamily="34" charset="0"/>
-              </a:rPr>
-              <a:t>Social Learning (PBL and PAL activities)</a:t>
+              <a:t>Algorithm Comparison</a:t>
             </a:r>
           </a:p>
         </p:txBody>
@@ -15047,7 +15077,7 @@
         </p:nvSpPr>
         <p:spPr>
           <a:xfrm>
-            <a:off x="33371596" y="5536712"/>
+            <a:off x="33427274" y="10182179"/>
             <a:ext cx="10048874" cy="846363"/>
           </a:xfrm>
         </p:spPr>
@@ -15063,7 +15093,7 @@
                 <a:latin typeface="Arial" panose="020B0604020202020204" pitchFamily="34" charset="0"/>
                 <a:cs typeface="Arial" panose="020B0604020202020204" pitchFamily="34" charset="0"/>
               </a:rPr>
-              <a:t>Self Efficacy</a:t>
+              <a:t>Staffing Recommendation Output</a:t>
             </a:r>
           </a:p>
         </p:txBody>
@@ -15080,8 +15110,8 @@
         </p:nvSpPr>
         <p:spPr>
           <a:xfrm>
-            <a:off x="33382622" y="6056596"/>
-            <a:ext cx="10052050" cy="4693570"/>
+            <a:off x="33392567" y="11064732"/>
+            <a:ext cx="10052050" cy="2769967"/>
           </a:xfrm>
         </p:spPr>
         <p:txBody>
@@ -15089,22 +15119,35 @@
           <a:lstStyle/>
           <a:p>
             <a:r>
-              <a:rPr lang="en-IE" dirty="0">
+              <a:rPr lang="en-US" dirty="0">
                 <a:solidFill>
                   <a:schemeClr val="tx1"/>
                 </a:solidFill>
                 <a:latin typeface="Arial" panose="020B0604020202020204" pitchFamily="34" charset="0"/>
                 <a:cs typeface="Arial" panose="020B0604020202020204" pitchFamily="34" charset="0"/>
               </a:rPr>
-              <a:t>Participants were provided a self-efficacy questionnaire, based on a approach suggested by Bandura (2006), to complete at the start and end of a semester. A social learning intervention was introduced to a treatment group, and the overall self-efficacy group score comparison revealed very little, other than a slight increase in the treatment group score.  However, a significant finding was found when comparing the final four questions measuring the perceived ability to work within a group. To illustrate this, the first figure below represents the start of semester self-efficacy group score for both groups, followed by the second figure representing the end of semester self-efficacy score reversal.</a:t>
+              <a:t>The model's predictions were converted into daily staffing recommendations using a ratio of one staff member per ten guests. The resulting bar chart provides hotel managers with a clear, </a:t>
             </a:r>
-            <a:endParaRPr lang="en-US" dirty="0">
-              <a:solidFill>
-                <a:schemeClr val="tx1"/>
-              </a:solidFill>
-              <a:latin typeface="Arial" panose="020B0604020202020204" pitchFamily="34" charset="0"/>
-              <a:cs typeface="Arial" panose="020B0604020202020204" pitchFamily="34" charset="0"/>
-            </a:endParaRPr>
+            <a:r>
+              <a:rPr lang="en-US" dirty="0" err="1">
+                <a:solidFill>
+                  <a:schemeClr val="tx1"/>
+                </a:solidFill>
+                <a:latin typeface="Arial" panose="020B0604020202020204" pitchFamily="34" charset="0"/>
+                <a:cs typeface="Arial" panose="020B0604020202020204" pitchFamily="34" charset="0"/>
+              </a:rPr>
+              <a:t>colour</a:t>
+            </a:r>
+            <a:r>
+              <a:rPr lang="en-US" dirty="0">
+                <a:solidFill>
+                  <a:schemeClr val="tx1"/>
+                </a:solidFill>
+                <a:latin typeface="Arial" panose="020B0604020202020204" pitchFamily="34" charset="0"/>
+                <a:cs typeface="Arial" panose="020B0604020202020204" pitchFamily="34" charset="0"/>
+              </a:rPr>
+              <a:t>-coded visual output showing recommended staff numbers for upcoming days — directly addressing the original business objective of reducing staffing inefficiency.</a:t>
+            </a:r>
           </a:p>
         </p:txBody>
       </p:sp>
@@ -15284,8 +15327,8 @@
         </p:nvSpPr>
         <p:spPr>
           <a:xfrm>
-            <a:off x="22534004" y="7077748"/>
-            <a:ext cx="9795691" cy="5522693"/>
+            <a:off x="22508758" y="6927638"/>
+            <a:ext cx="9795691" cy="4729644"/>
           </a:xfrm>
           <a:prstGeom prst="rect">
             <a:avLst/>
@@ -15437,144 +15480,18 @@
               <a:buNone/>
             </a:pPr>
             <a:r>
-              <a:rPr lang="en-IE" sz="2500" dirty="0"/>
-              <a:t>A reflective learning journal was provided to student participants in two of the action research studies, participants were asked to complete this journal on a weekly basis over the course of a semester.  There was mixed opinions on the use of the journal, with the majority questioning its usefulness.  Students were not convinced of the benefits of using the journal over a long period of time, and found the activity a burden in some cases.  Some viewed it as a piece of additional assessment that had no grade, furthering most to question the benefits.   While some positive benefits were noticed, careful consideration is required if using such a tool for a class cohort, some individuals seemed to adapt better to this type of journaling activity than others.   </a:t>
+              <a:rPr lang="en-US" sz="2500" dirty="0"/>
+              <a:t>Three candidate algorithms were evaluated using </a:t>
             </a:r>
-          </a:p>
-        </p:txBody>
-      </p:sp>
-      <p:sp>
-        <p:nvSpPr>
-          <p:cNvPr id="38" name="Text Placeholder 11"/>
-          <p:cNvSpPr>
-            <a:spLocks noGrp="1"/>
-          </p:cNvSpPr>
-          <p:nvPr>
-            <p:ph type="body" sz="quarter" idx="28"/>
-          </p:nvPr>
-        </p:nvSpPr>
-        <p:spPr>
-          <a:xfrm>
-            <a:off x="22407466" y="25936012"/>
-            <a:ext cx="10052050" cy="6490985"/>
-          </a:xfrm>
-        </p:spPr>
-        <p:txBody>
-          <a:bodyPr/>
-          <a:lstStyle/>
-          <a:p>
             <a:r>
-              <a:rPr lang="en-IE" dirty="0">
-                <a:solidFill>
-                  <a:schemeClr val="tx1"/>
-                </a:solidFill>
-                <a:latin typeface="Arial" panose="020B0604020202020204" pitchFamily="34" charset="0"/>
-                <a:cs typeface="Arial" panose="020B0604020202020204" pitchFamily="34" charset="0"/>
-              </a:rPr>
-              <a:t>Problem Based Learning (PBL) and Peer Assisted Learning (PAL) were introduced to a treatment group over the course of a semester.  The quotes below represent a small sample of the overall positive feedback the participants expressed in terms of their enjoyment in participating in groups when solving programming problems:</a:t>
+              <a:rPr lang="en-US" sz="2500" dirty="0" err="1"/>
+              <a:t>TimeSeriesSplit</a:t>
             </a:r>
-          </a:p>
-          <a:p>
-            <a:endParaRPr lang="en-IE" dirty="0">
-              <a:solidFill>
-                <a:schemeClr val="tx1"/>
-              </a:solidFill>
-              <a:latin typeface="Arial" panose="020B0604020202020204" pitchFamily="34" charset="0"/>
-              <a:cs typeface="Arial" panose="020B0604020202020204" pitchFamily="34" charset="0"/>
-            </a:endParaRPr>
-          </a:p>
-          <a:p>
             <a:r>
-              <a:rPr lang="en-IE" sz="1600" i="1" dirty="0">
-                <a:solidFill>
-                  <a:schemeClr val="tx1"/>
-                </a:solidFill>
-                <a:latin typeface="Arial" panose="020B0604020202020204" pitchFamily="34" charset="0"/>
-                <a:cs typeface="Arial" panose="020B0604020202020204" pitchFamily="34" charset="0"/>
-              </a:rPr>
-              <a:t>“I learned I can work in a group. Although I most of the times would rather work alone, working in a group does make problem solving a lot easier”.</a:t>
+              <a:rPr lang="en-US" sz="2500" dirty="0"/>
+              <a:t> cross-validation across 5 folds. All three algorithms produced negative average R² scores during cross-validation, which is expected given the small training folds in early splits. However, Random Forest consistently outperformed the others, achieving the highest average R² of -0.2470 and the most stable results across folds. When trained on the full training set of 634 days, the Random Forest model achieved a final R² of 0.7133 on the held-out test set.</a:t>
             </a:r>
-          </a:p>
-          <a:p>
-            <a:endParaRPr lang="en-IE" sz="1600" i="1" dirty="0">
-              <a:solidFill>
-                <a:schemeClr val="tx1"/>
-              </a:solidFill>
-              <a:latin typeface="Arial" panose="020B0604020202020204" pitchFamily="34" charset="0"/>
-              <a:cs typeface="Arial" panose="020B0604020202020204" pitchFamily="34" charset="0"/>
-            </a:endParaRPr>
-          </a:p>
-          <a:p>
-            <a:r>
-              <a:rPr lang="en-IE" sz="1600" i="1" dirty="0">
-                <a:solidFill>
-                  <a:schemeClr val="tx1"/>
-                </a:solidFill>
-                <a:latin typeface="Arial" panose="020B0604020202020204" pitchFamily="34" charset="0"/>
-                <a:cs typeface="Arial" panose="020B0604020202020204" pitchFamily="34" charset="0"/>
-              </a:rPr>
-              <a:t>“I enjoy programming but I’m 100% aware that my planning skills are way better than my programming skills. I wish we had more opportunities like this one to practice”.</a:t>
-            </a:r>
-          </a:p>
-          <a:p>
-            <a:endParaRPr lang="en-IE" sz="1600" i="1" dirty="0">
-              <a:solidFill>
-                <a:schemeClr val="tx1"/>
-              </a:solidFill>
-              <a:latin typeface="Arial" panose="020B0604020202020204" pitchFamily="34" charset="0"/>
-              <a:cs typeface="Arial" panose="020B0604020202020204" pitchFamily="34" charset="0"/>
-            </a:endParaRPr>
-          </a:p>
-          <a:p>
-            <a:r>
-              <a:rPr lang="en-IE" sz="1600" i="1" dirty="0">
-                <a:solidFill>
-                  <a:schemeClr val="tx1"/>
-                </a:solidFill>
-                <a:latin typeface="Arial" panose="020B0604020202020204" pitchFamily="34" charset="0"/>
-                <a:cs typeface="Arial" panose="020B0604020202020204" pitchFamily="34" charset="0"/>
-              </a:rPr>
-              <a:t>“Really enjoyable as I am better working with people.  (I’m a really nervous person and individual evaluations makes me so nervous that I cannot concentrate)”.</a:t>
-            </a:r>
-          </a:p>
-          <a:p>
-            <a:endParaRPr lang="en-IE" sz="1600" i="1" dirty="0">
-              <a:solidFill>
-                <a:schemeClr val="tx1"/>
-              </a:solidFill>
-              <a:latin typeface="Arial" panose="020B0604020202020204" pitchFamily="34" charset="0"/>
-              <a:cs typeface="Arial" panose="020B0604020202020204" pitchFamily="34" charset="0"/>
-            </a:endParaRPr>
-          </a:p>
-          <a:p>
-            <a:r>
-              <a:rPr lang="en-IE" sz="1600" i="1" dirty="0">
-                <a:solidFill>
-                  <a:schemeClr val="tx1"/>
-                </a:solidFill>
-                <a:latin typeface="Arial" panose="020B0604020202020204" pitchFamily="34" charset="0"/>
-                <a:cs typeface="Arial" panose="020B0604020202020204" pitchFamily="34" charset="0"/>
-              </a:rPr>
-              <a:t>“These activities really makes more interaction among friends and for a given problem, we can solve it with many the best ways.  And need to be continued in the coming weeks”.</a:t>
-            </a:r>
-          </a:p>
-          <a:p>
-            <a:endParaRPr lang="en-IE" sz="1600" i="1" dirty="0">
-              <a:solidFill>
-                <a:schemeClr val="tx1"/>
-              </a:solidFill>
-              <a:latin typeface="Arial" panose="020B0604020202020204" pitchFamily="34" charset="0"/>
-              <a:cs typeface="Arial" panose="020B0604020202020204" pitchFamily="34" charset="0"/>
-            </a:endParaRPr>
-          </a:p>
-          <a:p>
-            <a:endParaRPr lang="en-IE" sz="1600" i="1" dirty="0">
-              <a:solidFill>
-                <a:schemeClr val="tx1"/>
-              </a:solidFill>
-              <a:latin typeface="Arial" panose="020B0604020202020204" pitchFamily="34" charset="0"/>
-              <a:cs typeface="Arial" panose="020B0604020202020204" pitchFamily="34" charset="0"/>
-            </a:endParaRPr>
+            <a:endParaRPr lang="en-IE" sz="2500" dirty="0"/>
           </a:p>
         </p:txBody>
       </p:sp>
@@ -15780,8 +15697,8 @@
         </p:nvSpPr>
         <p:spPr>
           <a:xfrm>
-            <a:off x="33513137" y="22823005"/>
-            <a:ext cx="9736942" cy="5408649"/>
+            <a:off x="33513137" y="19818089"/>
+            <a:ext cx="9736942" cy="8413565"/>
           </a:xfrm>
           <a:prstGeom prst="rect">
             <a:avLst/>
@@ -15971,11 +15888,11 @@
               <a:t> 	</a:t>
             </a:r>
             <a:r>
-              <a:rPr lang="en-IE" sz="2200" i="1" dirty="0">
+              <a:rPr lang="en-US" sz="2200" i="1" dirty="0">
                 <a:latin typeface="Arial" panose="020B0604020202020204" pitchFamily="34" charset="0"/>
                 <a:cs typeface="Arial" panose="020B0604020202020204" pitchFamily="34" charset="0"/>
               </a:rPr>
-              <a:t>Both of the studies on the use of a reflective learning journal were 	mostly negative, in that students did not find it beneficial, and in some 	cases, saw it as an additional ungraded piece of assessment .</a:t>
+              <a:t>Yes. Combining hotel booking history, Met Éireann weather data, and Dublin events data produced a model that successfully predicts daily occupancy, achieving an R² of 0.7133 on unseen test data. Historical occupancy lag features proved to be the strongest predictors, confirming that recent booking patterns carry the most signal.</a:t>
             </a:r>
           </a:p>
           <a:p>
@@ -15995,14 +15912,14 @@
                 <a:latin typeface="Arial" panose="020B0604020202020204" pitchFamily="34" charset="0"/>
                 <a:cs typeface="Arial" panose="020B0604020202020204" pitchFamily="34" charset="0"/>
               </a:rPr>
-              <a:t>	There was </a:t>
+              <a:t>	</a:t>
             </a:r>
             <a:r>
-              <a:rPr lang="en-IE" sz="2200" i="1" dirty="0">
+              <a:rPr lang="en-US" sz="2200" dirty="0">
                 <a:latin typeface="Arial" panose="020B0604020202020204" pitchFamily="34" charset="0"/>
                 <a:cs typeface="Arial" panose="020B0604020202020204" pitchFamily="34" charset="0"/>
               </a:rPr>
-              <a:t>evidence to suggest it does, specifically relating to 	group based activities, and communicating with peers.  However, it is 	difficult to say positive findings were directly linked to the social 	learning activities introduced over the semester.</a:t>
+              <a:t>Random Forest Regression outperformed both Linear Regression and Decision Tree across all cross-validation folds. Linear Regression failed to capture the non-linear demand patterns in the data, while Random Forest's ensemble approach produced the most stable and accurate results, confirmed by the lowest standard deviation across folds.</a:t>
             </a:r>
             <a:endParaRPr lang="en-IE" sz="2200" dirty="0">
               <a:latin typeface="Arial" panose="020B0604020202020204" pitchFamily="34" charset="0"/>
@@ -16029,16 +15946,15 @@
               <a:t>	</a:t>
             </a:r>
             <a:r>
-              <a:rPr lang="en-IE" sz="2200" i="1" dirty="0">
+              <a:rPr lang="en-US" sz="2200" i="1" dirty="0">
                 <a:latin typeface="Arial" panose="020B0604020202020204" pitchFamily="34" charset="0"/>
                 <a:cs typeface="Arial" panose="020B0604020202020204" pitchFamily="34" charset="0"/>
               </a:rPr>
-              <a:t>The use of PBL and PAL was very successful in engaging students in 	computer programming, the students engaged in the activities and 	requested more of these activities in the future.</a:t>
+              <a:t>The impact was critical. Defining occupancy as daily arrivals rather than nightly guests present caused the model to fail completely, producing an R² of -0.2051. Correcting this single definition transformed model performance to R² = 0.7133 ,demonstrating that an incorrectly defined target variable cannot be overcome by any amount of feature engineering or algorithm tuning.</a:t>
             </a:r>
           </a:p>
           <a:p>
             <a:pPr marL="0" indent="0" defTabSz="895350">
-              <a:buFont typeface="Arial" pitchFamily="34" charset="0"/>
               <a:buNone/>
             </a:pPr>
             <a:r>
@@ -16056,1880 +15972,19 @@
               <a:t>	</a:t>
             </a:r>
             <a:r>
-              <a:rPr lang="en-IE" sz="2200" i="1" dirty="0">
+              <a:rPr lang="en-US" sz="2200" i="1" dirty="0">
                 <a:latin typeface="Arial" panose="020B0604020202020204" pitchFamily="34" charset="0"/>
                 <a:cs typeface="Arial" panose="020B0604020202020204" pitchFamily="34" charset="0"/>
               </a:rPr>
-              <a:t>There was no strong evidence to suggest social learning improved 	self-efficacy in computer programming, however, there was strong 	evidence found that participating in group work enhances self-efficacy 	in working with others in group activities.</a:t>
+              <a:t>Yes. Applying a ratio of one staff member per ten guests, the model's MAE of 16.66 guests translates to an average staffing error of 1–2 staff per day, an operationally acceptable margin for weekly planning. The output is visualized as a color-coded bar chart suitable for deployment via a Power BI dashboard.</a:t>
             </a:r>
+            <a:endParaRPr lang="en-IE" sz="2200" i="1" dirty="0">
+              <a:latin typeface="Arial" panose="020B0604020202020204" pitchFamily="34" charset="0"/>
+              <a:cs typeface="Arial" panose="020B0604020202020204" pitchFamily="34" charset="0"/>
+            </a:endParaRPr>
           </a:p>
         </p:txBody>
       </p:sp>
-      <p:graphicFrame>
-        <p:nvGraphicFramePr>
-          <p:cNvPr id="37" name="Table 36"/>
-          <p:cNvGraphicFramePr>
-            <a:graphicFrameLocks noGrp="1"/>
-          </p:cNvGraphicFramePr>
-          <p:nvPr>
-            <p:extLst>
-              <p:ext uri="{D42A27DB-BD31-4B8C-83A1-F6EECF244321}">
-                <p14:modId xmlns:p14="http://schemas.microsoft.com/office/powerpoint/2010/main" val="3349645228"/>
-              </p:ext>
-            </p:extLst>
-          </p:nvPr>
-        </p:nvGraphicFramePr>
-        <p:xfrm>
-          <a:off x="11653912" y="26870112"/>
-          <a:ext cx="9742489" cy="5042448"/>
-        </p:xfrm>
-        <a:graphic>
-          <a:graphicData uri="http://schemas.openxmlformats.org/drawingml/2006/table">
-            <a:tbl>
-              <a:tblPr firstRow="1" firstCol="1" bandRow="1">
-                <a:tableStyleId>{5C22544A-7EE6-4342-B048-85BDC9FD1C3A}</a:tableStyleId>
-              </a:tblPr>
-              <a:tblGrid>
-                <a:gridCol w="7314070">
-                  <a:extLst>
-                    <a:ext uri="{9D8B030D-6E8A-4147-A177-3AD203B41FA5}">
-                      <a16:colId xmlns:a16="http://schemas.microsoft.com/office/drawing/2014/main" val="20000"/>
-                    </a:ext>
-                  </a:extLst>
-                </a:gridCol>
-                <a:gridCol w="1447800">
-                  <a:extLst>
-                    <a:ext uri="{9D8B030D-6E8A-4147-A177-3AD203B41FA5}">
-                      <a16:colId xmlns:a16="http://schemas.microsoft.com/office/drawing/2014/main" val="20001"/>
-                    </a:ext>
-                  </a:extLst>
-                </a:gridCol>
-                <a:gridCol w="980619">
-                  <a:extLst>
-                    <a:ext uri="{9D8B030D-6E8A-4147-A177-3AD203B41FA5}">
-                      <a16:colId xmlns:a16="http://schemas.microsoft.com/office/drawing/2014/main" val="20002"/>
-                    </a:ext>
-                  </a:extLst>
-                </a:gridCol>
-              </a:tblGrid>
-              <a:tr h="337853">
-                <a:tc gridSpan="3">
-                  <a:txBody>
-                    <a:bodyPr/>
-                    <a:lstStyle/>
-                    <a:p>
-                      <a:pPr>
-                        <a:spcAft>
-                          <a:spcPts val="0"/>
-                        </a:spcAft>
-                      </a:pPr>
-                      <a:endParaRPr lang="en-IE" sz="1000" dirty="0">
-                        <a:solidFill>
-                          <a:schemeClr val="tx1"/>
-                        </a:solidFill>
-                        <a:effectLst/>
-                        <a:latin typeface="Arial" panose="020B0604020202020204" pitchFamily="34" charset="0"/>
-                        <a:ea typeface="Times New Roman"/>
-                        <a:cs typeface="Arial" panose="020B0604020202020204" pitchFamily="34" charset="0"/>
-                      </a:endParaRPr>
-                    </a:p>
-                  </a:txBody>
-                  <a:tcPr marL="68580" marR="68580" marT="0" marB="0" anchor="ctr">
-                    <a:noFill/>
-                  </a:tcPr>
-                </a:tc>
-                <a:tc hMerge="1">
-                  <a:txBody>
-                    <a:bodyPr/>
-                    <a:lstStyle/>
-                    <a:p>
-                      <a:endParaRPr lang="en-IE"/>
-                    </a:p>
-                  </a:txBody>
-                  <a:tcPr/>
-                </a:tc>
-                <a:tc hMerge="1">
-                  <a:txBody>
-                    <a:bodyPr/>
-                    <a:lstStyle/>
-                    <a:p>
-                      <a:endParaRPr lang="en-IE"/>
-                    </a:p>
-                  </a:txBody>
-                  <a:tcPr/>
-                </a:tc>
-                <a:extLst>
-                  <a:ext uri="{0D108BD9-81ED-4DB2-BD59-A6C34878D82A}">
-                    <a16:rowId xmlns:a16="http://schemas.microsoft.com/office/drawing/2014/main" val="10000"/>
-                  </a:ext>
-                </a:extLst>
-              </a:tr>
-              <a:tr h="398339">
-                <a:tc>
-                  <a:txBody>
-                    <a:bodyPr/>
-                    <a:lstStyle/>
-                    <a:p>
-                      <a:pPr>
-                        <a:spcAft>
-                          <a:spcPts val="0"/>
-                        </a:spcAft>
-                      </a:pPr>
-                      <a:r>
-                        <a:rPr lang="en-IE" sz="1800" dirty="0">
-                          <a:solidFill>
-                            <a:schemeClr val="tx1"/>
-                          </a:solidFill>
-                          <a:effectLst/>
-                          <a:latin typeface="Arial" panose="020B0604020202020204" pitchFamily="34" charset="0"/>
-                          <a:ea typeface="Times New Roman"/>
-                          <a:cs typeface="Arial" panose="020B0604020202020204" pitchFamily="34" charset="0"/>
-                        </a:rPr>
-                        <a:t>Pilot Study -</a:t>
-                      </a:r>
-                      <a:r>
-                        <a:rPr lang="en-IE" sz="1800" baseline="0" dirty="0">
-                          <a:solidFill>
-                            <a:schemeClr val="tx1"/>
-                          </a:solidFill>
-                          <a:effectLst/>
-                          <a:latin typeface="Arial" panose="020B0604020202020204" pitchFamily="34" charset="0"/>
-                          <a:ea typeface="Times New Roman"/>
-                          <a:cs typeface="Arial" panose="020B0604020202020204" pitchFamily="34" charset="0"/>
-                        </a:rPr>
-                        <a:t> 2014</a:t>
-                      </a:r>
-                      <a:endParaRPr lang="en-IE" sz="1800" dirty="0">
-                        <a:solidFill>
-                          <a:schemeClr val="tx1"/>
-                        </a:solidFill>
-                        <a:effectLst/>
-                        <a:latin typeface="Arial" panose="020B0604020202020204" pitchFamily="34" charset="0"/>
-                        <a:ea typeface="Times New Roman"/>
-                        <a:cs typeface="Arial" panose="020B0604020202020204" pitchFamily="34" charset="0"/>
-                      </a:endParaRPr>
-                    </a:p>
-                  </a:txBody>
-                  <a:tcPr marL="68580" marR="68580" marT="0" marB="0" anchor="ctr">
-                    <a:solidFill>
-                      <a:schemeClr val="accent1"/>
-                    </a:solidFill>
-                  </a:tcPr>
-                </a:tc>
-                <a:tc>
-                  <a:txBody>
-                    <a:bodyPr/>
-                    <a:lstStyle/>
-                    <a:p>
-                      <a:pPr>
-                        <a:spcAft>
-                          <a:spcPts val="0"/>
-                        </a:spcAft>
-                      </a:pPr>
-                      <a:r>
-                        <a:rPr lang="en-GB" sz="1800" b="1" dirty="0">
-                          <a:solidFill>
-                            <a:schemeClr val="bg1"/>
-                          </a:solidFill>
-                          <a:effectLst/>
-                        </a:rPr>
-                        <a:t>Analysis</a:t>
-                      </a:r>
-                      <a:endParaRPr lang="en-IE" sz="1800" b="1" dirty="0">
-                        <a:solidFill>
-                          <a:schemeClr val="bg1"/>
-                        </a:solidFill>
-                        <a:effectLst/>
-                        <a:latin typeface="Times New Roman"/>
-                        <a:ea typeface="Times New Roman"/>
-                        <a:cs typeface="Times New Roman"/>
-                      </a:endParaRPr>
-                    </a:p>
-                  </a:txBody>
-                  <a:tcPr marL="68580" marR="68580" marT="0" marB="0" anchor="ctr">
-                    <a:solidFill>
-                      <a:schemeClr val="accent1"/>
-                    </a:solidFill>
-                  </a:tcPr>
-                </a:tc>
-                <a:tc>
-                  <a:txBody>
-                    <a:bodyPr/>
-                    <a:lstStyle/>
-                    <a:p>
-                      <a:pPr>
-                        <a:spcAft>
-                          <a:spcPts val="0"/>
-                        </a:spcAft>
-                      </a:pPr>
-                      <a:r>
-                        <a:rPr lang="en-GB" sz="1800" b="1" dirty="0">
-                          <a:solidFill>
-                            <a:schemeClr val="bg1"/>
-                          </a:solidFill>
-                          <a:effectLst/>
-                        </a:rPr>
-                        <a:t>Sample</a:t>
-                      </a:r>
-                      <a:endParaRPr lang="en-IE" sz="1800" b="1" dirty="0">
-                        <a:solidFill>
-                          <a:schemeClr val="bg1"/>
-                        </a:solidFill>
-                        <a:effectLst/>
-                        <a:latin typeface="Times New Roman"/>
-                        <a:ea typeface="Times New Roman"/>
-                        <a:cs typeface="Times New Roman"/>
-                      </a:endParaRPr>
-                    </a:p>
-                  </a:txBody>
-                  <a:tcPr marL="68580" marR="68580" marT="0" marB="0" anchor="ctr">
-                    <a:solidFill>
-                      <a:schemeClr val="accent1"/>
-                    </a:solidFill>
-                  </a:tcPr>
-                </a:tc>
-                <a:extLst>
-                  <a:ext uri="{0D108BD9-81ED-4DB2-BD59-A6C34878D82A}">
-                    <a16:rowId xmlns:a16="http://schemas.microsoft.com/office/drawing/2014/main" val="10001"/>
-                  </a:ext>
-                </a:extLst>
-              </a:tr>
-              <a:tr h="288187">
-                <a:tc>
-                  <a:txBody>
-                    <a:bodyPr/>
-                    <a:lstStyle/>
-                    <a:p>
-                      <a:pPr>
-                        <a:spcAft>
-                          <a:spcPts val="0"/>
-                        </a:spcAft>
-                      </a:pPr>
-                      <a:r>
-                        <a:rPr lang="en-GB" sz="1600" b="0" dirty="0">
-                          <a:solidFill>
-                            <a:schemeClr val="tx1"/>
-                          </a:solidFill>
-                          <a:effectLst/>
-                          <a:latin typeface="Arial" panose="020B0604020202020204" pitchFamily="34" charset="0"/>
-                          <a:cs typeface="Arial" panose="020B0604020202020204" pitchFamily="34" charset="0"/>
-                        </a:rPr>
-                        <a:t>Student study habits questionnaire</a:t>
-                      </a:r>
-                      <a:endParaRPr lang="en-IE" sz="1600" b="0" dirty="0">
-                        <a:solidFill>
-                          <a:schemeClr val="tx1"/>
-                        </a:solidFill>
-                        <a:effectLst/>
-                        <a:latin typeface="Arial" panose="020B0604020202020204" pitchFamily="34" charset="0"/>
-                        <a:ea typeface="Times New Roman"/>
-                        <a:cs typeface="Arial" panose="020B0604020202020204" pitchFamily="34" charset="0"/>
-                      </a:endParaRPr>
-                    </a:p>
-                  </a:txBody>
-                  <a:tcPr marL="68580" marR="68580" marT="0" marB="0" anchor="ctr">
-                    <a:solidFill>
-                      <a:schemeClr val="bg1">
-                        <a:lumMod val="85000"/>
-                      </a:schemeClr>
-                    </a:solidFill>
-                  </a:tcPr>
-                </a:tc>
-                <a:tc>
-                  <a:txBody>
-                    <a:bodyPr/>
-                    <a:lstStyle/>
-                    <a:p>
-                      <a:pPr>
-                        <a:spcAft>
-                          <a:spcPts val="0"/>
-                        </a:spcAft>
-                      </a:pPr>
-                      <a:r>
-                        <a:rPr lang="en-GB" sz="1600" b="0" dirty="0">
-                          <a:solidFill>
-                            <a:schemeClr val="tx1"/>
-                          </a:solidFill>
-                          <a:effectLst/>
-                          <a:latin typeface="Arial" panose="020B0604020202020204" pitchFamily="34" charset="0"/>
-                          <a:cs typeface="Arial" panose="020B0604020202020204" pitchFamily="34" charset="0"/>
-                        </a:rPr>
-                        <a:t>Quantitative</a:t>
-                      </a:r>
-                      <a:endParaRPr lang="en-IE" sz="1600" b="0" dirty="0">
-                        <a:solidFill>
-                          <a:schemeClr val="tx1"/>
-                        </a:solidFill>
-                        <a:effectLst/>
-                        <a:latin typeface="Arial" panose="020B0604020202020204" pitchFamily="34" charset="0"/>
-                        <a:ea typeface="Times New Roman"/>
-                        <a:cs typeface="Arial" panose="020B0604020202020204" pitchFamily="34" charset="0"/>
-                      </a:endParaRPr>
-                    </a:p>
-                  </a:txBody>
-                  <a:tcPr marL="68580" marR="68580" marT="0" marB="0" anchor="ctr">
-                    <a:solidFill>
-                      <a:schemeClr val="bg1">
-                        <a:lumMod val="85000"/>
-                      </a:schemeClr>
-                    </a:solidFill>
-                  </a:tcPr>
-                </a:tc>
-                <a:tc>
-                  <a:txBody>
-                    <a:bodyPr/>
-                    <a:lstStyle/>
-                    <a:p>
-                      <a:pPr algn="r">
-                        <a:spcAft>
-                          <a:spcPts val="0"/>
-                        </a:spcAft>
-                      </a:pPr>
-                      <a:r>
-                        <a:rPr lang="en-GB" sz="1600" b="0" dirty="0">
-                          <a:solidFill>
-                            <a:schemeClr val="tx1"/>
-                          </a:solidFill>
-                          <a:effectLst/>
-                          <a:latin typeface="Arial" panose="020B0604020202020204" pitchFamily="34" charset="0"/>
-                          <a:cs typeface="Arial" panose="020B0604020202020204" pitchFamily="34" charset="0"/>
-                        </a:rPr>
-                        <a:t>31</a:t>
-                      </a:r>
-                      <a:endParaRPr lang="en-IE" sz="1600" b="0" dirty="0">
-                        <a:solidFill>
-                          <a:schemeClr val="tx1"/>
-                        </a:solidFill>
-                        <a:effectLst/>
-                        <a:latin typeface="Arial" panose="020B0604020202020204" pitchFamily="34" charset="0"/>
-                        <a:ea typeface="Times New Roman"/>
-                        <a:cs typeface="Arial" panose="020B0604020202020204" pitchFamily="34" charset="0"/>
-                      </a:endParaRPr>
-                    </a:p>
-                  </a:txBody>
-                  <a:tcPr marL="68580" marR="68580" marT="0" marB="0">
-                    <a:solidFill>
-                      <a:schemeClr val="bg1">
-                        <a:lumMod val="85000"/>
-                      </a:schemeClr>
-                    </a:solidFill>
-                  </a:tcPr>
-                </a:tc>
-                <a:extLst>
-                  <a:ext uri="{0D108BD9-81ED-4DB2-BD59-A6C34878D82A}">
-                    <a16:rowId xmlns:a16="http://schemas.microsoft.com/office/drawing/2014/main" val="10002"/>
-                  </a:ext>
-                </a:extLst>
-              </a:tr>
-              <a:tr h="287383">
-                <a:tc>
-                  <a:txBody>
-                    <a:bodyPr/>
-                    <a:lstStyle/>
-                    <a:p>
-                      <a:pPr>
-                        <a:spcAft>
-                          <a:spcPts val="0"/>
-                        </a:spcAft>
-                      </a:pPr>
-                      <a:r>
-                        <a:rPr lang="en-GB" sz="1600" b="0" dirty="0">
-                          <a:solidFill>
-                            <a:schemeClr val="tx1"/>
-                          </a:solidFill>
-                          <a:effectLst/>
-                          <a:latin typeface="Arial" panose="020B0604020202020204" pitchFamily="34" charset="0"/>
-                          <a:cs typeface="Arial" panose="020B0604020202020204" pitchFamily="34" charset="0"/>
-                        </a:rPr>
-                        <a:t>Reflective Learning Journal</a:t>
-                      </a:r>
-                      <a:endParaRPr lang="en-IE" sz="1600" b="0" dirty="0">
-                        <a:solidFill>
-                          <a:schemeClr val="tx1"/>
-                        </a:solidFill>
-                        <a:effectLst/>
-                        <a:latin typeface="Arial" panose="020B0604020202020204" pitchFamily="34" charset="0"/>
-                        <a:ea typeface="Times New Roman"/>
-                        <a:cs typeface="Arial" panose="020B0604020202020204" pitchFamily="34" charset="0"/>
-                      </a:endParaRPr>
-                    </a:p>
-                  </a:txBody>
-                  <a:tcPr marL="68580" marR="68580" marT="0" marB="0" anchor="ctr">
-                    <a:solidFill>
-                      <a:schemeClr val="bg1">
-                        <a:lumMod val="85000"/>
-                      </a:schemeClr>
-                    </a:solidFill>
-                  </a:tcPr>
-                </a:tc>
-                <a:tc>
-                  <a:txBody>
-                    <a:bodyPr/>
-                    <a:lstStyle/>
-                    <a:p>
-                      <a:pPr>
-                        <a:spcAft>
-                          <a:spcPts val="0"/>
-                        </a:spcAft>
-                      </a:pPr>
-                      <a:r>
-                        <a:rPr lang="en-GB" sz="1600" b="0" dirty="0">
-                          <a:solidFill>
-                            <a:schemeClr val="tx1"/>
-                          </a:solidFill>
-                          <a:effectLst/>
-                          <a:latin typeface="Arial" panose="020B0604020202020204" pitchFamily="34" charset="0"/>
-                          <a:cs typeface="Arial" panose="020B0604020202020204" pitchFamily="34" charset="0"/>
-                        </a:rPr>
-                        <a:t>Qualitative</a:t>
-                      </a:r>
-                      <a:endParaRPr lang="en-IE" sz="1600" b="0" dirty="0">
-                        <a:solidFill>
-                          <a:schemeClr val="tx1"/>
-                        </a:solidFill>
-                        <a:effectLst/>
-                        <a:latin typeface="Arial" panose="020B0604020202020204" pitchFamily="34" charset="0"/>
-                        <a:ea typeface="Times New Roman"/>
-                        <a:cs typeface="Arial" panose="020B0604020202020204" pitchFamily="34" charset="0"/>
-                      </a:endParaRPr>
-                    </a:p>
-                  </a:txBody>
-                  <a:tcPr marL="68580" marR="68580" marT="0" marB="0" anchor="ctr">
-                    <a:solidFill>
-                      <a:schemeClr val="bg1">
-                        <a:lumMod val="85000"/>
-                      </a:schemeClr>
-                    </a:solidFill>
-                  </a:tcPr>
-                </a:tc>
-                <a:tc>
-                  <a:txBody>
-                    <a:bodyPr/>
-                    <a:lstStyle/>
-                    <a:p>
-                      <a:pPr algn="r">
-                        <a:spcAft>
-                          <a:spcPts val="0"/>
-                        </a:spcAft>
-                      </a:pPr>
-                      <a:r>
-                        <a:rPr lang="en-GB" sz="1600" b="0" dirty="0">
-                          <a:solidFill>
-                            <a:schemeClr val="tx1"/>
-                          </a:solidFill>
-                          <a:effectLst/>
-                          <a:latin typeface="Arial" panose="020B0604020202020204" pitchFamily="34" charset="0"/>
-                          <a:cs typeface="Arial" panose="020B0604020202020204" pitchFamily="34" charset="0"/>
-                        </a:rPr>
-                        <a:t>77</a:t>
-                      </a:r>
-                      <a:endParaRPr lang="en-IE" sz="1600" b="0" dirty="0">
-                        <a:solidFill>
-                          <a:schemeClr val="tx1"/>
-                        </a:solidFill>
-                        <a:effectLst/>
-                        <a:latin typeface="Arial" panose="020B0604020202020204" pitchFamily="34" charset="0"/>
-                        <a:ea typeface="Times New Roman"/>
-                        <a:cs typeface="Arial" panose="020B0604020202020204" pitchFamily="34" charset="0"/>
-                      </a:endParaRPr>
-                    </a:p>
-                  </a:txBody>
-                  <a:tcPr marL="68580" marR="68580" marT="0" marB="0">
-                    <a:solidFill>
-                      <a:schemeClr val="bg1">
-                        <a:lumMod val="85000"/>
-                      </a:schemeClr>
-                    </a:solidFill>
-                  </a:tcPr>
-                </a:tc>
-                <a:extLst>
-                  <a:ext uri="{0D108BD9-81ED-4DB2-BD59-A6C34878D82A}">
-                    <a16:rowId xmlns:a16="http://schemas.microsoft.com/office/drawing/2014/main" val="10003"/>
-                  </a:ext>
-                </a:extLst>
-              </a:tr>
-              <a:tr h="300446">
-                <a:tc>
-                  <a:txBody>
-                    <a:bodyPr/>
-                    <a:lstStyle/>
-                    <a:p>
-                      <a:pPr>
-                        <a:spcAft>
-                          <a:spcPts val="0"/>
-                        </a:spcAft>
-                      </a:pPr>
-                      <a:r>
-                        <a:rPr lang="en-GB" sz="1600" b="0" dirty="0">
-                          <a:solidFill>
-                            <a:schemeClr val="tx1"/>
-                          </a:solidFill>
-                          <a:effectLst/>
-                          <a:latin typeface="Arial" panose="020B0604020202020204" pitchFamily="34" charset="0"/>
-                          <a:cs typeface="Arial" panose="020B0604020202020204" pitchFamily="34" charset="0"/>
-                        </a:rPr>
-                        <a:t>Focus group (reflective journal evaluation)</a:t>
-                      </a:r>
-                      <a:endParaRPr lang="en-IE" sz="1600" b="0" dirty="0">
-                        <a:solidFill>
-                          <a:schemeClr val="tx1"/>
-                        </a:solidFill>
-                        <a:effectLst/>
-                        <a:latin typeface="Arial" panose="020B0604020202020204" pitchFamily="34" charset="0"/>
-                        <a:ea typeface="Times New Roman"/>
-                        <a:cs typeface="Arial" panose="020B0604020202020204" pitchFamily="34" charset="0"/>
-                      </a:endParaRPr>
-                    </a:p>
-                  </a:txBody>
-                  <a:tcPr marL="68580" marR="68580" marT="0" marB="0" anchor="ctr">
-                    <a:solidFill>
-                      <a:schemeClr val="bg1">
-                        <a:lumMod val="85000"/>
-                      </a:schemeClr>
-                    </a:solidFill>
-                  </a:tcPr>
-                </a:tc>
-                <a:tc>
-                  <a:txBody>
-                    <a:bodyPr/>
-                    <a:lstStyle/>
-                    <a:p>
-                      <a:pPr>
-                        <a:spcAft>
-                          <a:spcPts val="0"/>
-                        </a:spcAft>
-                      </a:pPr>
-                      <a:r>
-                        <a:rPr lang="en-GB" sz="1600" b="0" dirty="0">
-                          <a:solidFill>
-                            <a:schemeClr val="tx1"/>
-                          </a:solidFill>
-                          <a:effectLst/>
-                          <a:latin typeface="Arial" panose="020B0604020202020204" pitchFamily="34" charset="0"/>
-                          <a:cs typeface="Arial" panose="020B0604020202020204" pitchFamily="34" charset="0"/>
-                        </a:rPr>
-                        <a:t>Qualitative</a:t>
-                      </a:r>
-                      <a:endParaRPr lang="en-IE" sz="1600" b="0" dirty="0">
-                        <a:solidFill>
-                          <a:schemeClr val="tx1"/>
-                        </a:solidFill>
-                        <a:effectLst/>
-                        <a:latin typeface="Arial" panose="020B0604020202020204" pitchFamily="34" charset="0"/>
-                        <a:ea typeface="Times New Roman"/>
-                        <a:cs typeface="Arial" panose="020B0604020202020204" pitchFamily="34" charset="0"/>
-                      </a:endParaRPr>
-                    </a:p>
-                  </a:txBody>
-                  <a:tcPr marL="68580" marR="68580" marT="0" marB="0" anchor="ctr">
-                    <a:solidFill>
-                      <a:schemeClr val="bg1">
-                        <a:lumMod val="85000"/>
-                      </a:schemeClr>
-                    </a:solidFill>
-                  </a:tcPr>
-                </a:tc>
-                <a:tc>
-                  <a:txBody>
-                    <a:bodyPr/>
-                    <a:lstStyle/>
-                    <a:p>
-                      <a:pPr algn="r">
-                        <a:spcAft>
-                          <a:spcPts val="0"/>
-                        </a:spcAft>
-                      </a:pPr>
-                      <a:r>
-                        <a:rPr lang="en-GB" sz="1600" b="0" dirty="0">
-                          <a:solidFill>
-                            <a:schemeClr val="tx1"/>
-                          </a:solidFill>
-                          <a:effectLst/>
-                          <a:latin typeface="Arial" panose="020B0604020202020204" pitchFamily="34" charset="0"/>
-                          <a:cs typeface="Arial" panose="020B0604020202020204" pitchFamily="34" charset="0"/>
-                        </a:rPr>
-                        <a:t>7</a:t>
-                      </a:r>
-                      <a:endParaRPr lang="en-IE" sz="1600" b="0" dirty="0">
-                        <a:solidFill>
-                          <a:schemeClr val="tx1"/>
-                        </a:solidFill>
-                        <a:effectLst/>
-                        <a:latin typeface="Arial" panose="020B0604020202020204" pitchFamily="34" charset="0"/>
-                        <a:ea typeface="Times New Roman"/>
-                        <a:cs typeface="Arial" panose="020B0604020202020204" pitchFamily="34" charset="0"/>
-                      </a:endParaRPr>
-                    </a:p>
-                  </a:txBody>
-                  <a:tcPr marL="68580" marR="68580" marT="0" marB="0">
-                    <a:solidFill>
-                      <a:schemeClr val="bg1">
-                        <a:lumMod val="85000"/>
-                      </a:schemeClr>
-                    </a:solidFill>
-                  </a:tcPr>
-                </a:tc>
-                <a:extLst>
-                  <a:ext uri="{0D108BD9-81ED-4DB2-BD59-A6C34878D82A}">
-                    <a16:rowId xmlns:a16="http://schemas.microsoft.com/office/drawing/2014/main" val="10004"/>
-                  </a:ext>
-                </a:extLst>
-              </a:tr>
-              <a:tr h="0">
-                <a:tc gridSpan="3">
-                  <a:txBody>
-                    <a:bodyPr/>
-                    <a:lstStyle/>
-                    <a:p>
-                      <a:pPr>
-                        <a:spcAft>
-                          <a:spcPts val="0"/>
-                        </a:spcAft>
-                      </a:pPr>
-                      <a:endParaRPr lang="en-IE" sz="800" dirty="0">
-                        <a:solidFill>
-                          <a:schemeClr val="tx1"/>
-                        </a:solidFill>
-                        <a:effectLst/>
-                        <a:latin typeface="Arial" panose="020B0604020202020204" pitchFamily="34" charset="0"/>
-                        <a:ea typeface="Times New Roman"/>
-                        <a:cs typeface="Arial" panose="020B0604020202020204" pitchFamily="34" charset="0"/>
-                      </a:endParaRPr>
-                    </a:p>
-                  </a:txBody>
-                  <a:tcPr marL="68580" marR="68580" marT="0" marB="0" anchor="ctr">
-                    <a:noFill/>
-                  </a:tcPr>
-                </a:tc>
-                <a:tc hMerge="1">
-                  <a:txBody>
-                    <a:bodyPr/>
-                    <a:lstStyle/>
-                    <a:p>
-                      <a:endParaRPr lang="en-IE"/>
-                    </a:p>
-                  </a:txBody>
-                  <a:tcPr/>
-                </a:tc>
-                <a:tc hMerge="1">
-                  <a:txBody>
-                    <a:bodyPr/>
-                    <a:lstStyle/>
-                    <a:p>
-                      <a:endParaRPr lang="en-IE"/>
-                    </a:p>
-                  </a:txBody>
-                  <a:tcPr/>
-                </a:tc>
-                <a:extLst>
-                  <a:ext uri="{0D108BD9-81ED-4DB2-BD59-A6C34878D82A}">
-                    <a16:rowId xmlns:a16="http://schemas.microsoft.com/office/drawing/2014/main" val="10006"/>
-                  </a:ext>
-                </a:extLst>
-              </a:tr>
-              <a:tr h="398339">
-                <a:tc>
-                  <a:txBody>
-                    <a:bodyPr/>
-                    <a:lstStyle/>
-                    <a:p>
-                      <a:pPr>
-                        <a:spcAft>
-                          <a:spcPts val="0"/>
-                        </a:spcAft>
-                      </a:pPr>
-                      <a:r>
-                        <a:rPr lang="en-IE" sz="1800" dirty="0">
-                          <a:solidFill>
-                            <a:schemeClr val="tx1"/>
-                          </a:solidFill>
-                          <a:effectLst/>
-                          <a:latin typeface="Arial" panose="020B0604020202020204" pitchFamily="34" charset="0"/>
-                          <a:ea typeface="Times New Roman"/>
-                          <a:cs typeface="Arial" panose="020B0604020202020204" pitchFamily="34" charset="0"/>
-                        </a:rPr>
-                        <a:t>Secondary Study - 2015</a:t>
-                      </a:r>
-                    </a:p>
-                  </a:txBody>
-                  <a:tcPr marL="68580" marR="68580" marT="0" marB="0" anchor="ctr"/>
-                </a:tc>
-                <a:tc>
-                  <a:txBody>
-                    <a:bodyPr/>
-                    <a:lstStyle/>
-                    <a:p>
-                      <a:pPr marL="0" algn="l" defTabSz="4388900" rtl="0" eaLnBrk="1" latinLnBrk="0" hangingPunct="1">
-                        <a:spcAft>
-                          <a:spcPts val="0"/>
-                        </a:spcAft>
-                      </a:pPr>
-                      <a:r>
-                        <a:rPr lang="en-GB" sz="1800" b="1" kern="1200" dirty="0">
-                          <a:solidFill>
-                            <a:schemeClr val="lt1"/>
-                          </a:solidFill>
-                          <a:effectLst/>
-                          <a:latin typeface="+mn-lt"/>
-                          <a:ea typeface="+mn-ea"/>
-                          <a:cs typeface="+mn-cs"/>
-                        </a:rPr>
-                        <a:t>Analysis</a:t>
-                      </a:r>
-                      <a:endParaRPr lang="en-IE" sz="1800" b="1" kern="1200" dirty="0">
-                        <a:solidFill>
-                          <a:schemeClr val="lt1"/>
-                        </a:solidFill>
-                        <a:effectLst/>
-                        <a:latin typeface="+mn-lt"/>
-                        <a:ea typeface="+mn-ea"/>
-                        <a:cs typeface="+mn-cs"/>
-                      </a:endParaRPr>
-                    </a:p>
-                  </a:txBody>
-                  <a:tcPr marL="68580" marR="68580" marT="0" marB="0" anchor="ctr">
-                    <a:solidFill>
-                      <a:schemeClr val="accent1"/>
-                    </a:solidFill>
-                  </a:tcPr>
-                </a:tc>
-                <a:tc>
-                  <a:txBody>
-                    <a:bodyPr/>
-                    <a:lstStyle/>
-                    <a:p>
-                      <a:pPr marL="0" algn="l" defTabSz="4388900" rtl="0" eaLnBrk="1" latinLnBrk="0" hangingPunct="1">
-                        <a:spcAft>
-                          <a:spcPts val="0"/>
-                        </a:spcAft>
-                      </a:pPr>
-                      <a:r>
-                        <a:rPr lang="en-GB" sz="1800" b="1" kern="1200" dirty="0">
-                          <a:solidFill>
-                            <a:schemeClr val="lt1"/>
-                          </a:solidFill>
-                          <a:effectLst/>
-                          <a:latin typeface="+mn-lt"/>
-                          <a:ea typeface="+mn-ea"/>
-                          <a:cs typeface="+mn-cs"/>
-                        </a:rPr>
-                        <a:t>Sample</a:t>
-                      </a:r>
-                      <a:endParaRPr lang="en-IE" sz="1800" b="1" kern="1200" dirty="0">
-                        <a:solidFill>
-                          <a:schemeClr val="lt1"/>
-                        </a:solidFill>
-                        <a:effectLst/>
-                        <a:latin typeface="+mn-lt"/>
-                        <a:ea typeface="+mn-ea"/>
-                        <a:cs typeface="+mn-cs"/>
-                      </a:endParaRPr>
-                    </a:p>
-                  </a:txBody>
-                  <a:tcPr marL="68580" marR="68580" marT="0" marB="0" anchor="ctr">
-                    <a:solidFill>
-                      <a:schemeClr val="accent1"/>
-                    </a:solidFill>
-                  </a:tcPr>
-                </a:tc>
-                <a:extLst>
-                  <a:ext uri="{0D108BD9-81ED-4DB2-BD59-A6C34878D82A}">
-                    <a16:rowId xmlns:a16="http://schemas.microsoft.com/office/drawing/2014/main" val="10007"/>
-                  </a:ext>
-                </a:extLst>
-              </a:tr>
-              <a:tr h="289638">
-                <a:tc>
-                  <a:txBody>
-                    <a:bodyPr/>
-                    <a:lstStyle/>
-                    <a:p>
-                      <a:pPr>
-                        <a:spcAft>
-                          <a:spcPts val="0"/>
-                        </a:spcAft>
-                      </a:pPr>
-                      <a:r>
-                        <a:rPr lang="en-GB" sz="1600" b="0" dirty="0">
-                          <a:solidFill>
-                            <a:schemeClr val="tx1"/>
-                          </a:solidFill>
-                          <a:effectLst/>
-                          <a:latin typeface="Arial" panose="020B0604020202020204" pitchFamily="34" charset="0"/>
-                          <a:cs typeface="Arial" panose="020B0604020202020204" pitchFamily="34" charset="0"/>
-                        </a:rPr>
-                        <a:t>Student study habits questionnaire</a:t>
-                      </a:r>
-                      <a:endParaRPr lang="en-IE" sz="1600" b="0" dirty="0">
-                        <a:solidFill>
-                          <a:schemeClr val="tx1"/>
-                        </a:solidFill>
-                        <a:effectLst/>
-                        <a:latin typeface="Arial" panose="020B0604020202020204" pitchFamily="34" charset="0"/>
-                        <a:ea typeface="Times New Roman"/>
-                        <a:cs typeface="Arial" panose="020B0604020202020204" pitchFamily="34" charset="0"/>
-                      </a:endParaRPr>
-                    </a:p>
-                  </a:txBody>
-                  <a:tcPr marL="68580" marR="68580" marT="0" marB="0" anchor="ctr">
-                    <a:noFill/>
-                  </a:tcPr>
-                </a:tc>
-                <a:tc>
-                  <a:txBody>
-                    <a:bodyPr/>
-                    <a:lstStyle/>
-                    <a:p>
-                      <a:pPr>
-                        <a:spcAft>
-                          <a:spcPts val="0"/>
-                        </a:spcAft>
-                      </a:pPr>
-                      <a:r>
-                        <a:rPr lang="en-GB" sz="1600" b="0" dirty="0">
-                          <a:solidFill>
-                            <a:schemeClr val="tx1"/>
-                          </a:solidFill>
-                          <a:effectLst/>
-                          <a:latin typeface="Arial" panose="020B0604020202020204" pitchFamily="34" charset="0"/>
-                          <a:cs typeface="Arial" panose="020B0604020202020204" pitchFamily="34" charset="0"/>
-                        </a:rPr>
-                        <a:t>Quantitative</a:t>
-                      </a:r>
-                      <a:endParaRPr lang="en-IE" sz="1600" b="0" dirty="0">
-                        <a:solidFill>
-                          <a:schemeClr val="tx1"/>
-                        </a:solidFill>
-                        <a:effectLst/>
-                        <a:latin typeface="Arial" panose="020B0604020202020204" pitchFamily="34" charset="0"/>
-                        <a:ea typeface="Times New Roman"/>
-                        <a:cs typeface="Arial" panose="020B0604020202020204" pitchFamily="34" charset="0"/>
-                      </a:endParaRPr>
-                    </a:p>
-                  </a:txBody>
-                  <a:tcPr marL="68580" marR="68580" marT="0" marB="0" anchor="ctr">
-                    <a:noFill/>
-                  </a:tcPr>
-                </a:tc>
-                <a:tc>
-                  <a:txBody>
-                    <a:bodyPr/>
-                    <a:lstStyle/>
-                    <a:p>
-                      <a:pPr algn="r">
-                        <a:spcAft>
-                          <a:spcPts val="0"/>
-                        </a:spcAft>
-                      </a:pPr>
-                      <a:r>
-                        <a:rPr lang="en-GB" sz="1600" b="0" dirty="0">
-                          <a:solidFill>
-                            <a:schemeClr val="tx1"/>
-                          </a:solidFill>
-                          <a:effectLst/>
-                          <a:latin typeface="Arial" panose="020B0604020202020204" pitchFamily="34" charset="0"/>
-                          <a:cs typeface="Arial" panose="020B0604020202020204" pitchFamily="34" charset="0"/>
-                        </a:rPr>
-                        <a:t>53</a:t>
-                      </a:r>
-                      <a:endParaRPr lang="en-IE" sz="1600" b="0" dirty="0">
-                        <a:solidFill>
-                          <a:schemeClr val="tx1"/>
-                        </a:solidFill>
-                        <a:effectLst/>
-                        <a:latin typeface="Arial" panose="020B0604020202020204" pitchFamily="34" charset="0"/>
-                        <a:ea typeface="Times New Roman"/>
-                        <a:cs typeface="Arial" panose="020B0604020202020204" pitchFamily="34" charset="0"/>
-                      </a:endParaRPr>
-                    </a:p>
-                  </a:txBody>
-                  <a:tcPr marL="68580" marR="68580" marT="0" marB="0" anchor="ctr">
-                    <a:noFill/>
-                  </a:tcPr>
-                </a:tc>
-                <a:extLst>
-                  <a:ext uri="{0D108BD9-81ED-4DB2-BD59-A6C34878D82A}">
-                    <a16:rowId xmlns:a16="http://schemas.microsoft.com/office/drawing/2014/main" val="10008"/>
-                  </a:ext>
-                </a:extLst>
-              </a:tr>
-              <a:tr h="300445">
-                <a:tc>
-                  <a:txBody>
-                    <a:bodyPr/>
-                    <a:lstStyle/>
-                    <a:p>
-                      <a:pPr>
-                        <a:spcAft>
-                          <a:spcPts val="0"/>
-                        </a:spcAft>
-                      </a:pPr>
-                      <a:r>
-                        <a:rPr lang="en-GB" sz="1600" b="0" dirty="0">
-                          <a:solidFill>
-                            <a:schemeClr val="tx1"/>
-                          </a:solidFill>
-                          <a:effectLst/>
-                          <a:latin typeface="Arial" panose="020B0604020202020204" pitchFamily="34" charset="0"/>
-                          <a:cs typeface="Arial" panose="020B0604020202020204" pitchFamily="34" charset="0"/>
-                        </a:rPr>
-                        <a:t>Reflective Learning Journal</a:t>
-                      </a:r>
-                      <a:endParaRPr lang="en-IE" sz="1600" b="0" dirty="0">
-                        <a:solidFill>
-                          <a:schemeClr val="tx1"/>
-                        </a:solidFill>
-                        <a:effectLst/>
-                        <a:latin typeface="Arial" panose="020B0604020202020204" pitchFamily="34" charset="0"/>
-                        <a:ea typeface="Times New Roman"/>
-                        <a:cs typeface="Arial" panose="020B0604020202020204" pitchFamily="34" charset="0"/>
-                      </a:endParaRPr>
-                    </a:p>
-                  </a:txBody>
-                  <a:tcPr marL="68580" marR="68580" marT="0" marB="0" anchor="ctr">
-                    <a:noFill/>
-                  </a:tcPr>
-                </a:tc>
-                <a:tc>
-                  <a:txBody>
-                    <a:bodyPr/>
-                    <a:lstStyle/>
-                    <a:p>
-                      <a:pPr>
-                        <a:spcAft>
-                          <a:spcPts val="0"/>
-                        </a:spcAft>
-                      </a:pPr>
-                      <a:r>
-                        <a:rPr lang="en-GB" sz="1600" b="0" dirty="0">
-                          <a:solidFill>
-                            <a:schemeClr val="tx1"/>
-                          </a:solidFill>
-                          <a:effectLst/>
-                          <a:latin typeface="Arial" panose="020B0604020202020204" pitchFamily="34" charset="0"/>
-                          <a:cs typeface="Arial" panose="020B0604020202020204" pitchFamily="34" charset="0"/>
-                        </a:rPr>
-                        <a:t>Qualitative</a:t>
-                      </a:r>
-                      <a:endParaRPr lang="en-IE" sz="1600" b="0" dirty="0">
-                        <a:solidFill>
-                          <a:schemeClr val="tx1"/>
-                        </a:solidFill>
-                        <a:effectLst/>
-                        <a:latin typeface="Arial" panose="020B0604020202020204" pitchFamily="34" charset="0"/>
-                        <a:ea typeface="Times New Roman"/>
-                        <a:cs typeface="Arial" panose="020B0604020202020204" pitchFamily="34" charset="0"/>
-                      </a:endParaRPr>
-                    </a:p>
-                  </a:txBody>
-                  <a:tcPr marL="68580" marR="68580" marT="0" marB="0" anchor="ctr">
-                    <a:noFill/>
-                  </a:tcPr>
-                </a:tc>
-                <a:tc>
-                  <a:txBody>
-                    <a:bodyPr/>
-                    <a:lstStyle/>
-                    <a:p>
-                      <a:pPr algn="r">
-                        <a:spcAft>
-                          <a:spcPts val="0"/>
-                        </a:spcAft>
-                      </a:pPr>
-                      <a:r>
-                        <a:rPr lang="en-GB" sz="1600" b="0" dirty="0">
-                          <a:solidFill>
-                            <a:schemeClr val="tx1"/>
-                          </a:solidFill>
-                          <a:effectLst/>
-                          <a:latin typeface="Arial" panose="020B0604020202020204" pitchFamily="34" charset="0"/>
-                          <a:cs typeface="Arial" panose="020B0604020202020204" pitchFamily="34" charset="0"/>
-                        </a:rPr>
-                        <a:t>18</a:t>
-                      </a:r>
-                      <a:endParaRPr lang="en-IE" sz="1600" b="0" dirty="0">
-                        <a:solidFill>
-                          <a:schemeClr val="tx1"/>
-                        </a:solidFill>
-                        <a:effectLst/>
-                        <a:latin typeface="Arial" panose="020B0604020202020204" pitchFamily="34" charset="0"/>
-                        <a:ea typeface="Times New Roman"/>
-                        <a:cs typeface="Arial" panose="020B0604020202020204" pitchFamily="34" charset="0"/>
-                      </a:endParaRPr>
-                    </a:p>
-                  </a:txBody>
-                  <a:tcPr marL="68580" marR="68580" marT="0" marB="0" anchor="ctr">
-                    <a:noFill/>
-                  </a:tcPr>
-                </a:tc>
-                <a:extLst>
-                  <a:ext uri="{0D108BD9-81ED-4DB2-BD59-A6C34878D82A}">
-                    <a16:rowId xmlns:a16="http://schemas.microsoft.com/office/drawing/2014/main" val="10009"/>
-                  </a:ext>
-                </a:extLst>
-              </a:tr>
-              <a:tr h="274320">
-                <a:tc>
-                  <a:txBody>
-                    <a:bodyPr/>
-                    <a:lstStyle/>
-                    <a:p>
-                      <a:pPr>
-                        <a:spcAft>
-                          <a:spcPts val="0"/>
-                        </a:spcAft>
-                      </a:pPr>
-                      <a:r>
-                        <a:rPr lang="en-GB" sz="1600" b="0" dirty="0">
-                          <a:solidFill>
-                            <a:schemeClr val="tx1"/>
-                          </a:solidFill>
-                          <a:effectLst/>
-                          <a:latin typeface="Arial" panose="020B0604020202020204" pitchFamily="34" charset="0"/>
-                          <a:cs typeface="Arial" panose="020B0604020202020204" pitchFamily="34" charset="0"/>
-                        </a:rPr>
-                        <a:t>Interview (Journal evaluation and Study habits)</a:t>
-                      </a:r>
-                      <a:endParaRPr lang="en-IE" sz="1600" b="0" dirty="0">
-                        <a:solidFill>
-                          <a:schemeClr val="tx1"/>
-                        </a:solidFill>
-                        <a:effectLst/>
-                        <a:latin typeface="Arial" panose="020B0604020202020204" pitchFamily="34" charset="0"/>
-                        <a:ea typeface="Times New Roman"/>
-                        <a:cs typeface="Arial" panose="020B0604020202020204" pitchFamily="34" charset="0"/>
-                      </a:endParaRPr>
-                    </a:p>
-                  </a:txBody>
-                  <a:tcPr marL="68580" marR="68580" marT="0" marB="0" anchor="ctr">
-                    <a:noFill/>
-                  </a:tcPr>
-                </a:tc>
-                <a:tc>
-                  <a:txBody>
-                    <a:bodyPr/>
-                    <a:lstStyle/>
-                    <a:p>
-                      <a:pPr>
-                        <a:spcAft>
-                          <a:spcPts val="0"/>
-                        </a:spcAft>
-                      </a:pPr>
-                      <a:r>
-                        <a:rPr lang="en-GB" sz="1600" b="0" dirty="0">
-                          <a:solidFill>
-                            <a:schemeClr val="tx1"/>
-                          </a:solidFill>
-                          <a:effectLst/>
-                          <a:latin typeface="Arial" panose="020B0604020202020204" pitchFamily="34" charset="0"/>
-                          <a:cs typeface="Arial" panose="020B0604020202020204" pitchFamily="34" charset="0"/>
-                        </a:rPr>
-                        <a:t>Qualitative</a:t>
-                      </a:r>
-                      <a:endParaRPr lang="en-IE" sz="1600" b="0" dirty="0">
-                        <a:solidFill>
-                          <a:schemeClr val="tx1"/>
-                        </a:solidFill>
-                        <a:effectLst/>
-                        <a:latin typeface="Arial" panose="020B0604020202020204" pitchFamily="34" charset="0"/>
-                        <a:ea typeface="Times New Roman"/>
-                        <a:cs typeface="Arial" panose="020B0604020202020204" pitchFamily="34" charset="0"/>
-                      </a:endParaRPr>
-                    </a:p>
-                  </a:txBody>
-                  <a:tcPr marL="68580" marR="68580" marT="0" marB="0" anchor="ctr">
-                    <a:noFill/>
-                  </a:tcPr>
-                </a:tc>
-                <a:tc>
-                  <a:txBody>
-                    <a:bodyPr/>
-                    <a:lstStyle/>
-                    <a:p>
-                      <a:pPr algn="r">
-                        <a:spcAft>
-                          <a:spcPts val="0"/>
-                        </a:spcAft>
-                      </a:pPr>
-                      <a:r>
-                        <a:rPr lang="en-GB" sz="1600" b="0" dirty="0">
-                          <a:solidFill>
-                            <a:schemeClr val="tx1"/>
-                          </a:solidFill>
-                          <a:effectLst/>
-                          <a:latin typeface="Arial" panose="020B0604020202020204" pitchFamily="34" charset="0"/>
-                          <a:cs typeface="Arial" panose="020B0604020202020204" pitchFamily="34" charset="0"/>
-                        </a:rPr>
-                        <a:t>4</a:t>
-                      </a:r>
-                      <a:endParaRPr lang="en-IE" sz="1600" b="0" dirty="0">
-                        <a:solidFill>
-                          <a:schemeClr val="tx1"/>
-                        </a:solidFill>
-                        <a:effectLst/>
-                        <a:latin typeface="Arial" panose="020B0604020202020204" pitchFamily="34" charset="0"/>
-                        <a:ea typeface="Times New Roman"/>
-                        <a:cs typeface="Arial" panose="020B0604020202020204" pitchFamily="34" charset="0"/>
-                      </a:endParaRPr>
-                    </a:p>
-                  </a:txBody>
-                  <a:tcPr marL="68580" marR="68580" marT="0" marB="0" anchor="ctr">
-                    <a:noFill/>
-                  </a:tcPr>
-                </a:tc>
-                <a:extLst>
-                  <a:ext uri="{0D108BD9-81ED-4DB2-BD59-A6C34878D82A}">
-                    <a16:rowId xmlns:a16="http://schemas.microsoft.com/office/drawing/2014/main" val="10010"/>
-                  </a:ext>
-                </a:extLst>
-              </a:tr>
-              <a:tr h="0">
-                <a:tc gridSpan="3">
-                  <a:txBody>
-                    <a:bodyPr/>
-                    <a:lstStyle/>
-                    <a:p>
-                      <a:pPr>
-                        <a:spcAft>
-                          <a:spcPts val="0"/>
-                        </a:spcAft>
-                      </a:pPr>
-                      <a:endParaRPr lang="en-IE" sz="800" dirty="0">
-                        <a:solidFill>
-                          <a:schemeClr val="tx1"/>
-                        </a:solidFill>
-                        <a:effectLst/>
-                        <a:latin typeface="Arial" panose="020B0604020202020204" pitchFamily="34" charset="0"/>
-                        <a:ea typeface="Times New Roman"/>
-                        <a:cs typeface="Arial" panose="020B0604020202020204" pitchFamily="34" charset="0"/>
-                      </a:endParaRPr>
-                    </a:p>
-                  </a:txBody>
-                  <a:tcPr marL="68580" marR="68580" marT="0" marB="0" anchor="ctr">
-                    <a:noFill/>
-                  </a:tcPr>
-                </a:tc>
-                <a:tc hMerge="1">
-                  <a:txBody>
-                    <a:bodyPr/>
-                    <a:lstStyle/>
-                    <a:p>
-                      <a:endParaRPr lang="en-IE"/>
-                    </a:p>
-                  </a:txBody>
-                  <a:tcPr/>
-                </a:tc>
-                <a:tc hMerge="1">
-                  <a:txBody>
-                    <a:bodyPr/>
-                    <a:lstStyle/>
-                    <a:p>
-                      <a:endParaRPr lang="en-IE"/>
-                    </a:p>
-                  </a:txBody>
-                  <a:tcPr/>
-                </a:tc>
-                <a:extLst>
-                  <a:ext uri="{0D108BD9-81ED-4DB2-BD59-A6C34878D82A}">
-                    <a16:rowId xmlns:a16="http://schemas.microsoft.com/office/drawing/2014/main" val="10012"/>
-                  </a:ext>
-                </a:extLst>
-              </a:tr>
-              <a:tr h="398339">
-                <a:tc>
-                  <a:txBody>
-                    <a:bodyPr/>
-                    <a:lstStyle/>
-                    <a:p>
-                      <a:pPr>
-                        <a:spcAft>
-                          <a:spcPts val="0"/>
-                        </a:spcAft>
-                      </a:pPr>
-                      <a:r>
-                        <a:rPr lang="en-IE" sz="1800" dirty="0">
-                          <a:solidFill>
-                            <a:schemeClr val="tx1"/>
-                          </a:solidFill>
-                          <a:effectLst/>
-                          <a:latin typeface="Arial" panose="020B0604020202020204" pitchFamily="34" charset="0"/>
-                          <a:ea typeface="Times New Roman"/>
-                          <a:cs typeface="Arial" panose="020B0604020202020204" pitchFamily="34" charset="0"/>
-                        </a:rPr>
-                        <a:t>Principal Study - 2016</a:t>
-                      </a:r>
-                    </a:p>
-                  </a:txBody>
-                  <a:tcPr marL="68580" marR="68580" marT="0" marB="0" anchor="ctr"/>
-                </a:tc>
-                <a:tc>
-                  <a:txBody>
-                    <a:bodyPr/>
-                    <a:lstStyle/>
-                    <a:p>
-                      <a:pPr marL="0" algn="l" defTabSz="4388900" rtl="0" eaLnBrk="1" latinLnBrk="0" hangingPunct="1">
-                        <a:spcAft>
-                          <a:spcPts val="0"/>
-                        </a:spcAft>
-                      </a:pPr>
-                      <a:r>
-                        <a:rPr lang="en-GB" sz="2000" b="1" kern="1200" dirty="0">
-                          <a:solidFill>
-                            <a:schemeClr val="lt1"/>
-                          </a:solidFill>
-                          <a:effectLst/>
-                          <a:latin typeface="+mn-lt"/>
-                          <a:ea typeface="+mn-ea"/>
-                          <a:cs typeface="+mn-cs"/>
-                        </a:rPr>
-                        <a:t>Analysis</a:t>
-                      </a:r>
-                      <a:endParaRPr lang="en-IE" sz="2000" b="1" kern="1200" dirty="0">
-                        <a:solidFill>
-                          <a:schemeClr val="lt1"/>
-                        </a:solidFill>
-                        <a:effectLst/>
-                        <a:latin typeface="+mn-lt"/>
-                        <a:ea typeface="+mn-ea"/>
-                        <a:cs typeface="+mn-cs"/>
-                      </a:endParaRPr>
-                    </a:p>
-                  </a:txBody>
-                  <a:tcPr marL="68580" marR="68580" marT="0" marB="0" anchor="ctr">
-                    <a:solidFill>
-                      <a:schemeClr val="accent1"/>
-                    </a:solidFill>
-                  </a:tcPr>
-                </a:tc>
-                <a:tc>
-                  <a:txBody>
-                    <a:bodyPr/>
-                    <a:lstStyle/>
-                    <a:p>
-                      <a:pPr marL="0" algn="l" defTabSz="4388900" rtl="0" eaLnBrk="1" latinLnBrk="0" hangingPunct="1">
-                        <a:spcAft>
-                          <a:spcPts val="0"/>
-                        </a:spcAft>
-                      </a:pPr>
-                      <a:r>
-                        <a:rPr lang="en-GB" sz="2000" b="1" kern="1200" dirty="0">
-                          <a:solidFill>
-                            <a:schemeClr val="lt1"/>
-                          </a:solidFill>
-                          <a:effectLst/>
-                          <a:latin typeface="+mn-lt"/>
-                          <a:ea typeface="+mn-ea"/>
-                          <a:cs typeface="+mn-cs"/>
-                        </a:rPr>
-                        <a:t>Sample</a:t>
-                      </a:r>
-                      <a:endParaRPr lang="en-IE" sz="2000" b="1" kern="1200" dirty="0">
-                        <a:solidFill>
-                          <a:schemeClr val="lt1"/>
-                        </a:solidFill>
-                        <a:effectLst/>
-                        <a:latin typeface="+mn-lt"/>
-                        <a:ea typeface="+mn-ea"/>
-                        <a:cs typeface="+mn-cs"/>
-                      </a:endParaRPr>
-                    </a:p>
-                  </a:txBody>
-                  <a:tcPr marL="68580" marR="68580" marT="0" marB="0" anchor="ctr">
-                    <a:solidFill>
-                      <a:schemeClr val="accent1"/>
-                    </a:solidFill>
-                  </a:tcPr>
-                </a:tc>
-                <a:extLst>
-                  <a:ext uri="{0D108BD9-81ED-4DB2-BD59-A6C34878D82A}">
-                    <a16:rowId xmlns:a16="http://schemas.microsoft.com/office/drawing/2014/main" val="10013"/>
-                  </a:ext>
-                </a:extLst>
-              </a:tr>
-              <a:tr h="289639">
-                <a:tc>
-                  <a:txBody>
-                    <a:bodyPr/>
-                    <a:lstStyle/>
-                    <a:p>
-                      <a:pPr marL="0" algn="l" defTabSz="4388900" rtl="0" eaLnBrk="1" latinLnBrk="0" hangingPunct="1">
-                        <a:spcAft>
-                          <a:spcPts val="0"/>
-                        </a:spcAft>
-                      </a:pPr>
-                      <a:r>
-                        <a:rPr lang="en-IE" sz="1600" b="0" kern="1200" dirty="0">
-                          <a:solidFill>
-                            <a:schemeClr val="tx1"/>
-                          </a:solidFill>
-                          <a:effectLst/>
-                          <a:latin typeface="Arial" panose="020B0604020202020204" pitchFamily="34" charset="0"/>
-                          <a:ea typeface="+mn-ea"/>
-                          <a:cs typeface="Arial" panose="020B0604020202020204" pitchFamily="34" charset="0"/>
-                        </a:rPr>
-                        <a:t>Student Engagement &amp; Self-Efficacy Questionnaire – (Treatment</a:t>
-                      </a:r>
-                      <a:r>
-                        <a:rPr lang="en-IE" sz="1600" b="0" kern="1200" baseline="0" dirty="0">
-                          <a:solidFill>
-                            <a:schemeClr val="tx1"/>
-                          </a:solidFill>
-                          <a:effectLst/>
-                          <a:latin typeface="Arial" panose="020B0604020202020204" pitchFamily="34" charset="0"/>
-                          <a:ea typeface="+mn-ea"/>
-                          <a:cs typeface="Arial" panose="020B0604020202020204" pitchFamily="34" charset="0"/>
-                        </a:rPr>
-                        <a:t> Group)</a:t>
-                      </a:r>
-                      <a:endParaRPr lang="en-IE" sz="1600" b="0" kern="1200" dirty="0">
-                        <a:solidFill>
-                          <a:schemeClr val="tx1"/>
-                        </a:solidFill>
-                        <a:effectLst/>
-                        <a:latin typeface="Arial" panose="020B0604020202020204" pitchFamily="34" charset="0"/>
-                        <a:ea typeface="+mn-ea"/>
-                        <a:cs typeface="Arial" panose="020B0604020202020204" pitchFamily="34" charset="0"/>
-                      </a:endParaRPr>
-                    </a:p>
-                  </a:txBody>
-                  <a:tcPr marL="68580" marR="68580" marT="0" marB="0" anchor="ctr">
-                    <a:noFill/>
-                  </a:tcPr>
-                </a:tc>
-                <a:tc>
-                  <a:txBody>
-                    <a:bodyPr/>
-                    <a:lstStyle/>
-                    <a:p>
-                      <a:pPr>
-                        <a:spcAft>
-                          <a:spcPts val="0"/>
-                        </a:spcAft>
-                      </a:pPr>
-                      <a:r>
-                        <a:rPr lang="en-GB" sz="1600" b="0" dirty="0">
-                          <a:solidFill>
-                            <a:schemeClr val="tx1"/>
-                          </a:solidFill>
-                          <a:effectLst/>
-                          <a:latin typeface="Arial" panose="020B0604020202020204" pitchFamily="34" charset="0"/>
-                          <a:cs typeface="Arial" panose="020B0604020202020204" pitchFamily="34" charset="0"/>
-                        </a:rPr>
-                        <a:t>Quantitative</a:t>
-                      </a:r>
-                      <a:endParaRPr lang="en-IE" sz="1600" b="0" dirty="0">
-                        <a:solidFill>
-                          <a:schemeClr val="tx1"/>
-                        </a:solidFill>
-                        <a:effectLst/>
-                        <a:latin typeface="Arial" panose="020B0604020202020204" pitchFamily="34" charset="0"/>
-                        <a:ea typeface="Times New Roman"/>
-                        <a:cs typeface="Arial" panose="020B0604020202020204" pitchFamily="34" charset="0"/>
-                      </a:endParaRPr>
-                    </a:p>
-                  </a:txBody>
-                  <a:tcPr marL="68580" marR="68580" marT="0" marB="0" anchor="ctr">
-                    <a:noFill/>
-                  </a:tcPr>
-                </a:tc>
-                <a:tc>
-                  <a:txBody>
-                    <a:bodyPr/>
-                    <a:lstStyle/>
-                    <a:p>
-                      <a:pPr algn="r">
-                        <a:spcAft>
-                          <a:spcPts val="0"/>
-                        </a:spcAft>
-                      </a:pPr>
-                      <a:r>
-                        <a:rPr lang="en-GB" sz="1600" b="0" dirty="0">
-                          <a:solidFill>
-                            <a:schemeClr val="tx1"/>
-                          </a:solidFill>
-                          <a:effectLst/>
-                          <a:latin typeface="Arial" panose="020B0604020202020204" pitchFamily="34" charset="0"/>
-                          <a:cs typeface="Arial" panose="020B0604020202020204" pitchFamily="34" charset="0"/>
-                        </a:rPr>
-                        <a:t>44</a:t>
-                      </a:r>
-                      <a:endParaRPr lang="en-IE" sz="1600" b="0" dirty="0">
-                        <a:solidFill>
-                          <a:schemeClr val="tx1"/>
-                        </a:solidFill>
-                        <a:effectLst/>
-                        <a:latin typeface="Arial" panose="020B0604020202020204" pitchFamily="34" charset="0"/>
-                        <a:ea typeface="Times New Roman"/>
-                        <a:cs typeface="Arial" panose="020B0604020202020204" pitchFamily="34" charset="0"/>
-                      </a:endParaRPr>
-                    </a:p>
-                  </a:txBody>
-                  <a:tcPr marL="68580" marR="68580" marT="0" marB="0" anchor="ctr">
-                    <a:noFill/>
-                  </a:tcPr>
-                </a:tc>
-                <a:extLst>
-                  <a:ext uri="{0D108BD9-81ED-4DB2-BD59-A6C34878D82A}">
-                    <a16:rowId xmlns:a16="http://schemas.microsoft.com/office/drawing/2014/main" val="10014"/>
-                  </a:ext>
-                </a:extLst>
-              </a:tr>
-              <a:tr h="326571">
-                <a:tc>
-                  <a:txBody>
-                    <a:bodyPr/>
-                    <a:lstStyle/>
-                    <a:p>
-                      <a:pPr marL="0" algn="l" defTabSz="4388900" rtl="0" eaLnBrk="1" latinLnBrk="0" hangingPunct="1">
-                        <a:spcAft>
-                          <a:spcPts val="0"/>
-                        </a:spcAft>
-                      </a:pPr>
-                      <a:r>
-                        <a:rPr lang="en-IE" sz="1600" b="0" kern="1200" dirty="0">
-                          <a:solidFill>
-                            <a:schemeClr val="tx1"/>
-                          </a:solidFill>
-                          <a:effectLst/>
-                          <a:latin typeface="Arial" panose="020B0604020202020204" pitchFamily="34" charset="0"/>
-                          <a:ea typeface="+mn-ea"/>
-                          <a:cs typeface="Arial" panose="020B0604020202020204" pitchFamily="34" charset="0"/>
-                        </a:rPr>
-                        <a:t>Student Engagement &amp; Self-Efficacy Questionnaire –(Control)</a:t>
-                      </a:r>
-                    </a:p>
-                  </a:txBody>
-                  <a:tcPr marL="68580" marR="68580" marT="0" marB="0" anchor="ctr">
-                    <a:noFill/>
-                  </a:tcPr>
-                </a:tc>
-                <a:tc>
-                  <a:txBody>
-                    <a:bodyPr/>
-                    <a:lstStyle/>
-                    <a:p>
-                      <a:pPr>
-                        <a:spcAft>
-                          <a:spcPts val="0"/>
-                        </a:spcAft>
-                      </a:pPr>
-                      <a:r>
-                        <a:rPr lang="en-GB" sz="1600" b="0" dirty="0">
-                          <a:solidFill>
-                            <a:schemeClr val="tx1"/>
-                          </a:solidFill>
-                          <a:effectLst/>
-                          <a:latin typeface="Arial" panose="020B0604020202020204" pitchFamily="34" charset="0"/>
-                          <a:cs typeface="Arial" panose="020B0604020202020204" pitchFamily="34" charset="0"/>
-                        </a:rPr>
-                        <a:t>Quantitative</a:t>
-                      </a:r>
-                      <a:endParaRPr lang="en-IE" sz="1600" b="0" dirty="0">
-                        <a:solidFill>
-                          <a:schemeClr val="tx1"/>
-                        </a:solidFill>
-                        <a:effectLst/>
-                        <a:latin typeface="Arial" panose="020B0604020202020204" pitchFamily="34" charset="0"/>
-                        <a:ea typeface="Times New Roman"/>
-                        <a:cs typeface="Arial" panose="020B0604020202020204" pitchFamily="34" charset="0"/>
-                      </a:endParaRPr>
-                    </a:p>
-                  </a:txBody>
-                  <a:tcPr marL="68580" marR="68580" marT="0" marB="0" anchor="ctr">
-                    <a:noFill/>
-                  </a:tcPr>
-                </a:tc>
-                <a:tc>
-                  <a:txBody>
-                    <a:bodyPr/>
-                    <a:lstStyle/>
-                    <a:p>
-                      <a:pPr algn="r">
-                        <a:spcAft>
-                          <a:spcPts val="0"/>
-                        </a:spcAft>
-                      </a:pPr>
-                      <a:r>
-                        <a:rPr lang="en-GB" sz="1600" b="0" dirty="0">
-                          <a:solidFill>
-                            <a:schemeClr val="tx1"/>
-                          </a:solidFill>
-                          <a:effectLst/>
-                          <a:latin typeface="Arial" panose="020B0604020202020204" pitchFamily="34" charset="0"/>
-                          <a:cs typeface="Arial" panose="020B0604020202020204" pitchFamily="34" charset="0"/>
-                        </a:rPr>
-                        <a:t>31</a:t>
-                      </a:r>
-                      <a:endParaRPr lang="en-IE" sz="1600" b="0" dirty="0">
-                        <a:solidFill>
-                          <a:schemeClr val="tx1"/>
-                        </a:solidFill>
-                        <a:effectLst/>
-                        <a:latin typeface="Arial" panose="020B0604020202020204" pitchFamily="34" charset="0"/>
-                        <a:ea typeface="Times New Roman"/>
-                        <a:cs typeface="Arial" panose="020B0604020202020204" pitchFamily="34" charset="0"/>
-                      </a:endParaRPr>
-                    </a:p>
-                  </a:txBody>
-                  <a:tcPr marL="68580" marR="68580" marT="0" marB="0" anchor="ctr">
-                    <a:noFill/>
-                  </a:tcPr>
-                </a:tc>
-                <a:extLst>
-                  <a:ext uri="{0D108BD9-81ED-4DB2-BD59-A6C34878D82A}">
-                    <a16:rowId xmlns:a16="http://schemas.microsoft.com/office/drawing/2014/main" val="10015"/>
-                  </a:ext>
-                </a:extLst>
-              </a:tr>
-              <a:tr h="300446">
-                <a:tc>
-                  <a:txBody>
-                    <a:bodyPr/>
-                    <a:lstStyle/>
-                    <a:p>
-                      <a:pPr>
-                        <a:spcAft>
-                          <a:spcPts val="0"/>
-                        </a:spcAft>
-                      </a:pPr>
-                      <a:r>
-                        <a:rPr lang="en-IE" sz="1600" b="0" dirty="0">
-                          <a:solidFill>
-                            <a:schemeClr val="tx1"/>
-                          </a:solidFill>
-                          <a:effectLst/>
-                          <a:latin typeface="Arial" panose="020B0604020202020204" pitchFamily="34" charset="0"/>
-                          <a:cs typeface="Arial" panose="020B0604020202020204" pitchFamily="34" charset="0"/>
-                        </a:rPr>
-                        <a:t>Interview (start and end of semester with principal programming lecturer )</a:t>
-                      </a:r>
-                      <a:endParaRPr lang="en-IE" sz="1600" b="0" dirty="0">
-                        <a:solidFill>
-                          <a:schemeClr val="tx1"/>
-                        </a:solidFill>
-                        <a:effectLst/>
-                        <a:latin typeface="Arial" panose="020B0604020202020204" pitchFamily="34" charset="0"/>
-                        <a:ea typeface="Times New Roman"/>
-                        <a:cs typeface="Arial" panose="020B0604020202020204" pitchFamily="34" charset="0"/>
-                      </a:endParaRPr>
-                    </a:p>
-                  </a:txBody>
-                  <a:tcPr marL="68580" marR="68580" marT="0" marB="0" anchor="ctr">
-                    <a:noFill/>
-                  </a:tcPr>
-                </a:tc>
-                <a:tc>
-                  <a:txBody>
-                    <a:bodyPr/>
-                    <a:lstStyle/>
-                    <a:p>
-                      <a:pPr>
-                        <a:spcAft>
-                          <a:spcPts val="0"/>
-                        </a:spcAft>
-                      </a:pPr>
-                      <a:r>
-                        <a:rPr lang="en-GB" sz="1600" b="0" dirty="0">
-                          <a:solidFill>
-                            <a:schemeClr val="tx1"/>
-                          </a:solidFill>
-                          <a:effectLst/>
-                          <a:latin typeface="Arial" panose="020B0604020202020204" pitchFamily="34" charset="0"/>
-                          <a:cs typeface="Arial" panose="020B0604020202020204" pitchFamily="34" charset="0"/>
-                        </a:rPr>
-                        <a:t>Qualitative</a:t>
-                      </a:r>
-                      <a:endParaRPr lang="en-IE" sz="1600" b="0" dirty="0">
-                        <a:solidFill>
-                          <a:schemeClr val="tx1"/>
-                        </a:solidFill>
-                        <a:effectLst/>
-                        <a:latin typeface="Arial" panose="020B0604020202020204" pitchFamily="34" charset="0"/>
-                        <a:ea typeface="Times New Roman"/>
-                        <a:cs typeface="Arial" panose="020B0604020202020204" pitchFamily="34" charset="0"/>
-                      </a:endParaRPr>
-                    </a:p>
-                  </a:txBody>
-                  <a:tcPr marL="68580" marR="68580" marT="0" marB="0" anchor="ctr">
-                    <a:noFill/>
-                  </a:tcPr>
-                </a:tc>
-                <a:tc>
-                  <a:txBody>
-                    <a:bodyPr/>
-                    <a:lstStyle/>
-                    <a:p>
-                      <a:pPr algn="r">
-                        <a:spcAft>
-                          <a:spcPts val="0"/>
-                        </a:spcAft>
-                      </a:pPr>
-                      <a:r>
-                        <a:rPr lang="en-GB" sz="1600" b="0" dirty="0">
-                          <a:solidFill>
-                            <a:schemeClr val="tx1"/>
-                          </a:solidFill>
-                          <a:effectLst/>
-                          <a:latin typeface="Arial" panose="020B0604020202020204" pitchFamily="34" charset="0"/>
-                          <a:cs typeface="Arial" panose="020B0604020202020204" pitchFamily="34" charset="0"/>
-                        </a:rPr>
-                        <a:t>1</a:t>
-                      </a:r>
-                      <a:endParaRPr lang="en-IE" sz="1600" b="0" dirty="0">
-                        <a:solidFill>
-                          <a:schemeClr val="tx1"/>
-                        </a:solidFill>
-                        <a:effectLst/>
-                        <a:latin typeface="Arial" panose="020B0604020202020204" pitchFamily="34" charset="0"/>
-                        <a:ea typeface="Times New Roman"/>
-                        <a:cs typeface="Arial" panose="020B0604020202020204" pitchFamily="34" charset="0"/>
-                      </a:endParaRPr>
-                    </a:p>
-                  </a:txBody>
-                  <a:tcPr marL="68580" marR="68580" marT="0" marB="0" anchor="ctr">
-                    <a:noFill/>
-                  </a:tcPr>
-                </a:tc>
-                <a:extLst>
-                  <a:ext uri="{0D108BD9-81ED-4DB2-BD59-A6C34878D82A}">
-                    <a16:rowId xmlns:a16="http://schemas.microsoft.com/office/drawing/2014/main" val="10016"/>
-                  </a:ext>
-                </a:extLst>
-              </a:tr>
-              <a:tr h="300445">
-                <a:tc>
-                  <a:txBody>
-                    <a:bodyPr/>
-                    <a:lstStyle/>
-                    <a:p>
-                      <a:pPr>
-                        <a:spcAft>
-                          <a:spcPts val="0"/>
-                        </a:spcAft>
-                      </a:pPr>
-                      <a:r>
-                        <a:rPr lang="en-IE" sz="1600" b="0" dirty="0">
-                          <a:solidFill>
-                            <a:schemeClr val="tx1"/>
-                          </a:solidFill>
-                          <a:effectLst/>
-                          <a:latin typeface="Arial" panose="020B0604020202020204" pitchFamily="34" charset="0"/>
-                          <a:cs typeface="Arial" panose="020B0604020202020204" pitchFamily="34" charset="0"/>
-                        </a:rPr>
-                        <a:t>Interview (end of semester with treatment group participants)</a:t>
-                      </a:r>
-                      <a:endParaRPr lang="en-IE" sz="1600" b="0" dirty="0">
-                        <a:solidFill>
-                          <a:schemeClr val="tx1"/>
-                        </a:solidFill>
-                        <a:effectLst/>
-                        <a:latin typeface="Arial" panose="020B0604020202020204" pitchFamily="34" charset="0"/>
-                        <a:ea typeface="Times New Roman"/>
-                        <a:cs typeface="Arial" panose="020B0604020202020204" pitchFamily="34" charset="0"/>
-                      </a:endParaRPr>
-                    </a:p>
-                  </a:txBody>
-                  <a:tcPr marL="68580" marR="68580" marT="0" marB="0" anchor="ctr">
-                    <a:noFill/>
-                  </a:tcPr>
-                </a:tc>
-                <a:tc>
-                  <a:txBody>
-                    <a:bodyPr/>
-                    <a:lstStyle/>
-                    <a:p>
-                      <a:pPr>
-                        <a:spcAft>
-                          <a:spcPts val="0"/>
-                        </a:spcAft>
-                      </a:pPr>
-                      <a:r>
-                        <a:rPr lang="en-GB" sz="1600" b="0" dirty="0">
-                          <a:solidFill>
-                            <a:schemeClr val="tx1"/>
-                          </a:solidFill>
-                          <a:effectLst/>
-                          <a:latin typeface="Arial" panose="020B0604020202020204" pitchFamily="34" charset="0"/>
-                          <a:cs typeface="Arial" panose="020B0604020202020204" pitchFamily="34" charset="0"/>
-                        </a:rPr>
-                        <a:t>Qualitative</a:t>
-                      </a:r>
-                      <a:endParaRPr lang="en-IE" sz="1600" b="0" dirty="0">
-                        <a:solidFill>
-                          <a:schemeClr val="tx1"/>
-                        </a:solidFill>
-                        <a:effectLst/>
-                        <a:latin typeface="Arial" panose="020B0604020202020204" pitchFamily="34" charset="0"/>
-                        <a:ea typeface="Times New Roman"/>
-                        <a:cs typeface="Arial" panose="020B0604020202020204" pitchFamily="34" charset="0"/>
-                      </a:endParaRPr>
-                    </a:p>
-                  </a:txBody>
-                  <a:tcPr marL="68580" marR="68580" marT="0" marB="0" anchor="ctr">
-                    <a:noFill/>
-                  </a:tcPr>
-                </a:tc>
-                <a:tc>
-                  <a:txBody>
-                    <a:bodyPr/>
-                    <a:lstStyle/>
-                    <a:p>
-                      <a:pPr algn="r">
-                        <a:spcAft>
-                          <a:spcPts val="0"/>
-                        </a:spcAft>
-                      </a:pPr>
-                      <a:r>
-                        <a:rPr lang="en-GB" sz="1600" b="0" dirty="0">
-                          <a:solidFill>
-                            <a:schemeClr val="tx1"/>
-                          </a:solidFill>
-                          <a:effectLst/>
-                          <a:latin typeface="Arial" panose="020B0604020202020204" pitchFamily="34" charset="0"/>
-                          <a:cs typeface="Arial" panose="020B0604020202020204" pitchFamily="34" charset="0"/>
-                        </a:rPr>
-                        <a:t>4</a:t>
-                      </a:r>
-                      <a:endParaRPr lang="en-IE" sz="1600" b="0" dirty="0">
-                        <a:solidFill>
-                          <a:schemeClr val="tx1"/>
-                        </a:solidFill>
-                        <a:effectLst/>
-                        <a:latin typeface="Arial" panose="020B0604020202020204" pitchFamily="34" charset="0"/>
-                        <a:ea typeface="Times New Roman"/>
-                        <a:cs typeface="Arial" panose="020B0604020202020204" pitchFamily="34" charset="0"/>
-                      </a:endParaRPr>
-                    </a:p>
-                  </a:txBody>
-                  <a:tcPr marL="68580" marR="68580" marT="0" marB="0" anchor="ctr">
-                    <a:noFill/>
-                  </a:tcPr>
-                </a:tc>
-                <a:extLst>
-                  <a:ext uri="{0D108BD9-81ED-4DB2-BD59-A6C34878D82A}">
-                    <a16:rowId xmlns:a16="http://schemas.microsoft.com/office/drawing/2014/main" val="10017"/>
-                  </a:ext>
-                </a:extLst>
-              </a:tr>
-              <a:tr h="308218">
-                <a:tc>
-                  <a:txBody>
-                    <a:bodyPr/>
-                    <a:lstStyle/>
-                    <a:p>
-                      <a:pPr>
-                        <a:spcAft>
-                          <a:spcPts val="0"/>
-                        </a:spcAft>
-                      </a:pPr>
-                      <a:r>
-                        <a:rPr lang="en-IE" sz="1600" b="0" dirty="0">
-                          <a:solidFill>
-                            <a:schemeClr val="tx1"/>
-                          </a:solidFill>
-                          <a:effectLst/>
-                          <a:latin typeface="Arial" panose="020B0604020202020204" pitchFamily="34" charset="0"/>
-                          <a:cs typeface="Arial" panose="020B0604020202020204" pitchFamily="34" charset="0"/>
-                        </a:rPr>
-                        <a:t>PBL/PAL activity feedback forms (5x sessions)</a:t>
-                      </a:r>
-                      <a:endParaRPr lang="en-IE" sz="1600" b="0" dirty="0">
-                        <a:solidFill>
-                          <a:schemeClr val="tx1"/>
-                        </a:solidFill>
-                        <a:effectLst/>
-                        <a:latin typeface="Arial" panose="020B0604020202020204" pitchFamily="34" charset="0"/>
-                        <a:ea typeface="Times New Roman"/>
-                        <a:cs typeface="Arial" panose="020B0604020202020204" pitchFamily="34" charset="0"/>
-                      </a:endParaRPr>
-                    </a:p>
-                  </a:txBody>
-                  <a:tcPr marL="68580" marR="68580" marT="0" marB="0" anchor="ctr">
-                    <a:noFill/>
-                  </a:tcPr>
-                </a:tc>
-                <a:tc>
-                  <a:txBody>
-                    <a:bodyPr/>
-                    <a:lstStyle/>
-                    <a:p>
-                      <a:pPr>
-                        <a:spcAft>
-                          <a:spcPts val="0"/>
-                        </a:spcAft>
-                      </a:pPr>
-                      <a:r>
-                        <a:rPr lang="en-GB" sz="1600" b="0" dirty="0">
-                          <a:solidFill>
-                            <a:schemeClr val="tx1"/>
-                          </a:solidFill>
-                          <a:effectLst/>
-                          <a:latin typeface="Arial" panose="020B0604020202020204" pitchFamily="34" charset="0"/>
-                          <a:cs typeface="Arial" panose="020B0604020202020204" pitchFamily="34" charset="0"/>
-                        </a:rPr>
-                        <a:t>Qualitative</a:t>
-                      </a:r>
-                      <a:endParaRPr lang="en-IE" sz="1600" b="0" dirty="0">
-                        <a:solidFill>
-                          <a:schemeClr val="tx1"/>
-                        </a:solidFill>
-                        <a:effectLst/>
-                        <a:latin typeface="Arial" panose="020B0604020202020204" pitchFamily="34" charset="0"/>
-                        <a:ea typeface="Times New Roman"/>
-                        <a:cs typeface="Arial" panose="020B0604020202020204" pitchFamily="34" charset="0"/>
-                      </a:endParaRPr>
-                    </a:p>
-                  </a:txBody>
-                  <a:tcPr marL="68580" marR="68580" marT="0" marB="0" anchor="ctr">
-                    <a:noFill/>
-                  </a:tcPr>
-                </a:tc>
-                <a:tc>
-                  <a:txBody>
-                    <a:bodyPr/>
-                    <a:lstStyle/>
-                    <a:p>
-                      <a:pPr algn="r">
-                        <a:spcAft>
-                          <a:spcPts val="0"/>
-                        </a:spcAft>
-                      </a:pPr>
-                      <a:r>
-                        <a:rPr lang="en-GB" sz="1600" b="0" dirty="0">
-                          <a:solidFill>
-                            <a:schemeClr val="tx1"/>
-                          </a:solidFill>
-                          <a:effectLst/>
-                          <a:latin typeface="Arial" panose="020B0604020202020204" pitchFamily="34" charset="0"/>
-                          <a:cs typeface="Arial" panose="020B0604020202020204" pitchFamily="34" charset="0"/>
-                        </a:rPr>
-                        <a:t>46</a:t>
-                      </a:r>
-                      <a:endParaRPr lang="en-IE" sz="1600" b="0" dirty="0">
-                        <a:solidFill>
-                          <a:schemeClr val="tx1"/>
-                        </a:solidFill>
-                        <a:effectLst/>
-                        <a:latin typeface="Arial" panose="020B0604020202020204" pitchFamily="34" charset="0"/>
-                        <a:ea typeface="Times New Roman"/>
-                        <a:cs typeface="Arial" panose="020B0604020202020204" pitchFamily="34" charset="0"/>
-                      </a:endParaRPr>
-                    </a:p>
-                  </a:txBody>
-                  <a:tcPr marL="68580" marR="68580" marT="0" marB="0" anchor="ctr">
-                    <a:noFill/>
-                  </a:tcPr>
-                </a:tc>
-                <a:extLst>
-                  <a:ext uri="{0D108BD9-81ED-4DB2-BD59-A6C34878D82A}">
-                    <a16:rowId xmlns:a16="http://schemas.microsoft.com/office/drawing/2014/main" val="10018"/>
-                  </a:ext>
-                </a:extLst>
-              </a:tr>
-            </a:tbl>
-          </a:graphicData>
-        </a:graphic>
-      </p:graphicFrame>
       <p:sp>
         <p:nvSpPr>
           <p:cNvPr id="45" name="Text Placeholder 4"/>
@@ -18571,8 +16626,8 @@
         </p:nvSpPr>
         <p:spPr>
           <a:xfrm>
-            <a:off x="22531031" y="12554206"/>
-            <a:ext cx="9795691" cy="5522693"/>
+            <a:off x="22576982" y="17453027"/>
+            <a:ext cx="9428190" cy="3739855"/>
           </a:xfrm>
           <a:prstGeom prst="rect">
             <a:avLst/>
@@ -18724,9 +16779,18 @@
               <a:buNone/>
             </a:pPr>
             <a:r>
-              <a:rPr lang="en-IE" sz="2500" dirty="0"/>
-              <a:t>A student engagement measurement tool was provided to student participants at the start and end of a semester.  A social learning intervention was applied to a treatment group, and the engagement scores across both the control and treatment groups were measured.  The results revealed a small increase in total student engagement group score for the treatment group, but nothing significant. However, interesting findings were found in some of the individual questions, the figure below represents one an example of this, in which the treatment group had scored considerably higher than the control group in a question relating to understanding people dissimilar to themselves, which would have been influenced through the social learning activities that the treatment group participated in.  This, in itself, was an encouraging finding. </a:t>
+              <a:rPr lang="en-US" sz="2500" dirty="0"/>
+              <a:t>The feature importance analysis revealed that occupancy lag variables dominated the model's predictions. </a:t>
             </a:r>
+            <a:r>
+              <a:rPr lang="en-US" sz="2500" dirty="0" err="1"/>
+              <a:t>occupancy_yesterday</a:t>
+            </a:r>
+            <a:r>
+              <a:rPr lang="en-US" sz="2500" dirty="0"/>
+              <a:t> alone accounted for approximately 80% of prediction power, confirming that recent booking history is the strongest signal for nightly demand. Weather conditions, events, and day of week contributed minimal predictive weight, consistent with the EDA finding that Dublin city hotels maintain steady occupancy regardless of weather.</a:t>
+            </a:r>
+            <a:endParaRPr lang="en-IE" sz="2500" dirty="0"/>
           </a:p>
         </p:txBody>
       </p:sp>
@@ -18747,7 +16811,7 @@
         <p:spPr>
           <a:xfrm>
             <a:off x="33656519" y="29479722"/>
-            <a:ext cx="9736942" cy="2621175"/>
+            <a:ext cx="9593560" cy="2621175"/>
           </a:xfrm>
           <a:prstGeom prst="rect">
             <a:avLst/>
@@ -18903,7 +16967,7 @@
                 <a:latin typeface="Arial" panose="020B0604020202020204" pitchFamily="34" charset="0"/>
                 <a:cs typeface="Arial" panose="020B0604020202020204" pitchFamily="34" charset="0"/>
               </a:rPr>
-              <a:t>Bandura, A. (1986). Social Foundations of Thought and Action: Social Cognitive Theory. U.S.A: Pearson Education.</a:t>
+              <a:t>Müller, A.C. and Guido, S. (2016) Introduction to Machine Learning with Python: A Guide for Data Scientists. Chapter 4: Utilizing Expert Knowledge, p. 242. Available at: https://www.nrigroupindia.com/e-book/Introduction%20to%20Machine%20Learning%20with%20Python%20(%20PDFDrive.com%20)-min.pdf [Accessed 28 May 2026]. </a:t>
             </a:r>
           </a:p>
           <a:p>
@@ -18924,35 +16988,7 @@
                 <a:latin typeface="Arial" panose="020B0604020202020204" pitchFamily="34" charset="0"/>
                 <a:cs typeface="Arial" panose="020B0604020202020204" pitchFamily="34" charset="0"/>
               </a:rPr>
-              <a:t>Bandura, A. (2006). Guide for constructing self-efficacy scales. In F. </a:t>
-            </a:r>
-            <a:r>
-              <a:rPr lang="en-IE" sz="900" dirty="0" err="1">
-                <a:latin typeface="Arial" panose="020B0604020202020204" pitchFamily="34" charset="0"/>
-                <a:cs typeface="Arial" panose="020B0604020202020204" pitchFamily="34" charset="0"/>
-              </a:rPr>
-              <a:t>Pajares</a:t>
-            </a:r>
-            <a:r>
-              <a:rPr lang="en-IE" sz="900" dirty="0">
-                <a:latin typeface="Arial" panose="020B0604020202020204" pitchFamily="34" charset="0"/>
-                <a:cs typeface="Arial" panose="020B0604020202020204" pitchFamily="34" charset="0"/>
-              </a:rPr>
-              <a:t>, &amp; T. </a:t>
-            </a:r>
-            <a:r>
-              <a:rPr lang="en-IE" sz="900" dirty="0" err="1">
-                <a:latin typeface="Arial" panose="020B0604020202020204" pitchFamily="34" charset="0"/>
-                <a:cs typeface="Arial" panose="020B0604020202020204" pitchFamily="34" charset="0"/>
-              </a:rPr>
-              <a:t>Urdan</a:t>
-            </a:r>
-            <a:r>
-              <a:rPr lang="en-IE" sz="900" dirty="0">
-                <a:latin typeface="Arial" panose="020B0604020202020204" pitchFamily="34" charset="0"/>
-                <a:cs typeface="Arial" panose="020B0604020202020204" pitchFamily="34" charset="0"/>
-              </a:rPr>
-              <a:t> (Eds.), Adolescence and education: Vol. 5. Self efficacy and adolescence (pp. 307-337). Greenwich, CT: Information Age.</a:t>
+              <a:t>Li, S. (2019) Ocean Sea Breeze EDA and Time Series forecast for Occupancy, GitHub repository. Available at: https://github.com/susanli2016/Machine-Learning-with-Python/blob/master/Ocean%20Sea%20Breeze%20EDA%20and%20Time%20Series%20forecast%20for%20Occupancy.ipynb [Accessed 28 May 2026]. </a:t>
             </a:r>
           </a:p>
           <a:p>
@@ -18973,35 +17009,21 @@
                 <a:latin typeface="Arial" panose="020B0604020202020204" pitchFamily="34" charset="0"/>
                 <a:cs typeface="Arial" panose="020B0604020202020204" pitchFamily="34" charset="0"/>
               </a:rPr>
-              <a:t>Bogdan, R.C., </a:t>
+              <a:t>Pandas Developers (2021) Bug: Unexpected behaviour or documentation gap for </a:t>
             </a:r>
             <a:r>
               <a:rPr lang="en-IE" sz="900" dirty="0" err="1">
                 <a:latin typeface="Arial" panose="020B0604020202020204" pitchFamily="34" charset="0"/>
                 <a:cs typeface="Arial" panose="020B0604020202020204" pitchFamily="34" charset="0"/>
               </a:rPr>
-              <a:t>Biklin</a:t>
+              <a:t>pd.to_datetime</a:t>
             </a:r>
             <a:r>
               <a:rPr lang="en-IE" sz="900" dirty="0">
                 <a:latin typeface="Arial" panose="020B0604020202020204" pitchFamily="34" charset="0"/>
                 <a:cs typeface="Arial" panose="020B0604020202020204" pitchFamily="34" charset="0"/>
               </a:rPr>
-              <a:t>, S.K. (1998). Qualitative research for education: An introduction to theory and methods. (3rd edition).  Boston: </a:t>
-            </a:r>
-            <a:r>
-              <a:rPr lang="en-IE" sz="900" dirty="0" err="1">
-                <a:latin typeface="Arial" panose="020B0604020202020204" pitchFamily="34" charset="0"/>
-                <a:cs typeface="Arial" panose="020B0604020202020204" pitchFamily="34" charset="0"/>
-              </a:rPr>
-              <a:t>Allyn</a:t>
-            </a:r>
-            <a:r>
-              <a:rPr lang="en-IE" sz="900" dirty="0">
-                <a:latin typeface="Arial" panose="020B0604020202020204" pitchFamily="34" charset="0"/>
-                <a:cs typeface="Arial" panose="020B0604020202020204" pitchFamily="34" charset="0"/>
-              </a:rPr>
-              <a:t> and Bacon.</a:t>
+              <a:t> with specific formats, GitHub Issue #39142. Available at: https://github.com/pandas-dev/pandas/issues/39142 [Accessed 28 May 2026]. </a:t>
             </a:r>
           </a:p>
           <a:p>
@@ -19022,7 +17044,77 @@
                 <a:latin typeface="Arial" panose="020B0604020202020204" pitchFamily="34" charset="0"/>
                 <a:cs typeface="Arial" panose="020B0604020202020204" pitchFamily="34" charset="0"/>
               </a:rPr>
-              <a:t>Bryman, A. (2004). Social Research Methods.  U.K.: Oxford University Press.</a:t>
+              <a:t>Met Éireann (2017) Historical Data: Available Meteorological Observations, Met Éireann - The Irish Meteorological Service. Available at: https://www.met.ie/climate/available-data/historical-data [Accessed 28 May 2026]. </a:t>
+            </a:r>
+          </a:p>
+          <a:p>
+            <a:pPr marL="0" indent="0" algn="just" defTabSz="895350">
+              <a:buNone/>
+            </a:pPr>
+            <a:endParaRPr lang="en-IE" sz="900" dirty="0">
+              <a:latin typeface="Arial" panose="020B0604020202020204" pitchFamily="34" charset="0"/>
+              <a:cs typeface="Arial" panose="020B0604020202020204" pitchFamily="34" charset="0"/>
+            </a:endParaRPr>
+          </a:p>
+          <a:p>
+            <a:pPr marL="0" indent="0" algn="just" defTabSz="895350">
+              <a:buNone/>
+            </a:pPr>
+            <a:r>
+              <a:rPr lang="en-IE" sz="900" dirty="0" err="1">
+                <a:latin typeface="Arial" panose="020B0604020202020204" pitchFamily="34" charset="0"/>
+                <a:cs typeface="Arial" panose="020B0604020202020204" pitchFamily="34" charset="0"/>
+              </a:rPr>
+              <a:t>Mostipak</a:t>
+            </a:r>
+            <a:r>
+              <a:rPr lang="en-IE" sz="900" dirty="0">
+                <a:latin typeface="Arial" panose="020B0604020202020204" pitchFamily="34" charset="0"/>
+                <a:cs typeface="Arial" panose="020B0604020202020204" pitchFamily="34" charset="0"/>
+              </a:rPr>
+              <a:t>, J. (2020) Hotel Booking Demand Dataset, Kaggle Datasets. Available at: https://www.kaggle.com/datasets/jessemostipak/hotel-booking-demand [Accessed 28 May 2026]. </a:t>
+            </a:r>
+          </a:p>
+          <a:p>
+            <a:pPr marL="0" indent="0" algn="just" defTabSz="895350">
+              <a:buNone/>
+            </a:pPr>
+            <a:endParaRPr lang="en-IE" sz="900" dirty="0">
+              <a:latin typeface="Arial" panose="020B0604020202020204" pitchFamily="34" charset="0"/>
+              <a:cs typeface="Arial" panose="020B0604020202020204" pitchFamily="34" charset="0"/>
+            </a:endParaRPr>
+          </a:p>
+          <a:p>
+            <a:pPr marL="0" indent="0" algn="just" defTabSz="895350">
+              <a:buNone/>
+            </a:pPr>
+            <a:r>
+              <a:rPr lang="en-IE" sz="900" dirty="0" err="1">
+                <a:latin typeface="Arial" panose="020B0604020202020204" pitchFamily="34" charset="0"/>
+                <a:cs typeface="Arial" panose="020B0604020202020204" pitchFamily="34" charset="0"/>
+              </a:rPr>
+              <a:t>GeeksforGeeks</a:t>
+            </a:r>
+            <a:r>
+              <a:rPr lang="en-IE" sz="900" dirty="0">
+                <a:latin typeface="Arial" panose="020B0604020202020204" pitchFamily="34" charset="0"/>
+                <a:cs typeface="Arial" panose="020B0604020202020204" pitchFamily="34" charset="0"/>
+              </a:rPr>
+              <a:t> (2023) Python map() function, </a:t>
+            </a:r>
+            <a:r>
+              <a:rPr lang="en-IE" sz="900" dirty="0" err="1">
+                <a:latin typeface="Arial" panose="020B0604020202020204" pitchFamily="34" charset="0"/>
+                <a:cs typeface="Arial" panose="020B0604020202020204" pitchFamily="34" charset="0"/>
+              </a:rPr>
+              <a:t>GeeksforGeeks</a:t>
+            </a:r>
+            <a:r>
+              <a:rPr lang="en-IE" sz="900" dirty="0">
+                <a:latin typeface="Arial" panose="020B0604020202020204" pitchFamily="34" charset="0"/>
+                <a:cs typeface="Arial" panose="020B0604020202020204" pitchFamily="34" charset="0"/>
+              </a:rPr>
+              <a:t> Programming Reference. Available at: https://www.geeksforgeeks.org/python/python-map-function/ [Accessed 28 May 2026].</a:t>
             </a:r>
           </a:p>
           <a:p>
@@ -19043,7 +17135,7 @@
                 <a:latin typeface="Arial" panose="020B0604020202020204" pitchFamily="34" charset="0"/>
                 <a:cs typeface="Arial" panose="020B0604020202020204" pitchFamily="34" charset="0"/>
               </a:rPr>
-              <a:t>Creswell, J.W., Miller, G.A. (1997).  Research Methodologies and Doctoral Process.  New Directions for Higher Education, no.99.  U.S.A.: Wiley.</a:t>
+              <a:t>W3Schools (2022) Python String replace() Method, W3Schools Python Reference. Available at: https://www.w3schools.com/python/ref_string_replace.asp [Accessed 28 May 2026].</a:t>
             </a:r>
           </a:p>
           <a:p>
@@ -19054,65 +17146,6 @@
               <a:latin typeface="Arial" panose="020B0604020202020204" pitchFamily="34" charset="0"/>
               <a:cs typeface="Arial" panose="020B0604020202020204" pitchFamily="34" charset="0"/>
             </a:endParaRPr>
-          </a:p>
-          <a:p>
-            <a:pPr marL="0" indent="0" algn="just" defTabSz="895350">
-              <a:buNone/>
-            </a:pPr>
-            <a:r>
-              <a:rPr lang="en-IE" sz="900" dirty="0">
-                <a:latin typeface="Arial" panose="020B0604020202020204" pitchFamily="34" charset="0"/>
-                <a:cs typeface="Arial" panose="020B0604020202020204" pitchFamily="34" charset="0"/>
-              </a:rPr>
-              <a:t>Hamir, S., </a:t>
-            </a:r>
-            <a:r>
-              <a:rPr lang="en-IE" sz="900" dirty="0" err="1">
-                <a:latin typeface="Arial" panose="020B0604020202020204" pitchFamily="34" charset="0"/>
-                <a:cs typeface="Arial" panose="020B0604020202020204" pitchFamily="34" charset="0"/>
-              </a:rPr>
-              <a:t>Maion</a:t>
-            </a:r>
-            <a:r>
-              <a:rPr lang="en-IE" sz="900" dirty="0">
-                <a:latin typeface="Arial" panose="020B0604020202020204" pitchFamily="34" charset="0"/>
-                <a:cs typeface="Arial" panose="020B0604020202020204" pitchFamily="34" charset="0"/>
-              </a:rPr>
-              <a:t>, S., Tice, S., &amp; Wideman, A. (2015) Constructivism in</a:t>
-            </a:r>
-          </a:p>
-          <a:p>
-            <a:pPr marL="0" indent="0" algn="just" defTabSz="895350">
-              <a:buNone/>
-            </a:pPr>
-            <a:r>
-              <a:rPr lang="en-IE" sz="900" dirty="0">
-                <a:latin typeface="Arial" panose="020B0604020202020204" pitchFamily="34" charset="0"/>
-                <a:cs typeface="Arial" panose="020B0604020202020204" pitchFamily="34" charset="0"/>
-              </a:rPr>
-              <a:t>Education. Available at: http://constructivism512.weebly.com . Accessed 27th February 2018.</a:t>
-            </a:r>
-          </a:p>
-          <a:p>
-            <a:pPr marL="0" indent="0" algn="just" defTabSz="895350">
-              <a:buNone/>
-            </a:pPr>
-            <a:endParaRPr lang="en-IE" sz="900" dirty="0">
-              <a:latin typeface="Arial" panose="020B0604020202020204" pitchFamily="34" charset="0"/>
-              <a:cs typeface="Arial" panose="020B0604020202020204" pitchFamily="34" charset="0"/>
-            </a:endParaRPr>
-          </a:p>
-          <a:p>
-            <a:pPr marL="0" indent="0" algn="just" defTabSz="895350">
-              <a:buNone/>
-            </a:pPr>
-            <a:r>
-              <a:rPr lang="en-IE" sz="900" dirty="0">
-                <a:latin typeface="Arial" panose="020B0604020202020204" pitchFamily="34" charset="0"/>
-                <a:cs typeface="Arial" panose="020B0604020202020204" pitchFamily="34" charset="0"/>
-              </a:rPr>
-              <a:t>Miles, M.B., &amp; Huberman, A.M. (1994). Qualitative data analysis: A sourcebook of new methods.  Thousand Oaks, CA: Sage.</a:t>
-            </a:r>
           </a:p>
         </p:txBody>
       </p:sp>
@@ -19131,7 +17164,7 @@
           <p:nvPr/>
         </p:nvPicPr>
         <p:blipFill>
-          <a:blip r:embed="rId6"/>
+          <a:blip r:embed="rId3"/>
           <a:stretch>
             <a:fillRect/>
           </a:stretch>
@@ -19280,7 +17313,7 @@
           <p:nvPr/>
         </p:nvPicPr>
         <p:blipFill>
-          <a:blip r:embed="rId7"/>
+          <a:blip r:embed="rId4"/>
           <a:stretch>
             <a:fillRect/>
           </a:stretch>
@@ -19310,7 +17343,7 @@
           <p:nvPr/>
         </p:nvPicPr>
         <p:blipFill>
-          <a:blip r:embed="rId8"/>
+          <a:blip r:embed="rId5"/>
           <a:stretch>
             <a:fillRect/>
           </a:stretch>
@@ -19319,6 +17352,878 @@
           <a:xfrm>
             <a:off x="11877332" y="19283242"/>
             <a:ext cx="8992855" cy="5973009"/>
+          </a:xfrm>
+          <a:prstGeom prst="rect">
+            <a:avLst/>
+          </a:prstGeom>
+        </p:spPr>
+      </p:pic>
+      <p:pic>
+        <p:nvPicPr>
+          <p:cNvPr id="63" name="Picture 62">
+            <a:extLst>
+              <a:ext uri="{FF2B5EF4-FFF2-40B4-BE49-F238E27FC236}">
+                <a16:creationId xmlns:a16="http://schemas.microsoft.com/office/drawing/2014/main" id="{9B91F188-A1D1-4CD8-7891-C98C11932D18}"/>
+              </a:ext>
+            </a:extLst>
+          </p:cNvPr>
+          <p:cNvPicPr>
+            <a:picLocks noChangeAspect="1"/>
+          </p:cNvPicPr>
+          <p:nvPr/>
+        </p:nvPicPr>
+        <p:blipFill>
+          <a:blip r:embed="rId6"/>
+          <a:stretch>
+            <a:fillRect/>
+          </a:stretch>
+        </p:blipFill>
+        <p:spPr>
+          <a:xfrm>
+            <a:off x="11693941" y="26999889"/>
+            <a:ext cx="9494970" cy="4082199"/>
+          </a:xfrm>
+          <a:prstGeom prst="rect">
+            <a:avLst/>
+          </a:prstGeom>
+        </p:spPr>
+      </p:pic>
+      <p:pic>
+        <p:nvPicPr>
+          <p:cNvPr id="4096" name="Picture 4095">
+            <a:extLst>
+              <a:ext uri="{FF2B5EF4-FFF2-40B4-BE49-F238E27FC236}">
+                <a16:creationId xmlns:a16="http://schemas.microsoft.com/office/drawing/2014/main" id="{6A95C329-D2AC-9133-C0C1-DD740C493269}"/>
+              </a:ext>
+            </a:extLst>
+          </p:cNvPr>
+          <p:cNvPicPr>
+            <a:picLocks noChangeAspect="1"/>
+          </p:cNvPicPr>
+          <p:nvPr/>
+        </p:nvPicPr>
+        <p:blipFill>
+          <a:blip r:embed="rId7"/>
+          <a:stretch>
+            <a:fillRect/>
+          </a:stretch>
+        </p:blipFill>
+        <p:spPr>
+          <a:xfrm>
+            <a:off x="23110477" y="10170588"/>
+            <a:ext cx="8017223" cy="6266508"/>
+          </a:xfrm>
+          <a:prstGeom prst="rect">
+            <a:avLst/>
+          </a:prstGeom>
+        </p:spPr>
+      </p:pic>
+      <p:pic>
+        <p:nvPicPr>
+          <p:cNvPr id="4104" name="Picture 4103">
+            <a:extLst>
+              <a:ext uri="{FF2B5EF4-FFF2-40B4-BE49-F238E27FC236}">
+                <a16:creationId xmlns:a16="http://schemas.microsoft.com/office/drawing/2014/main" id="{AB271B9C-A9E4-6060-D7D1-0B357D9BFAB6}"/>
+              </a:ext>
+            </a:extLst>
+          </p:cNvPr>
+          <p:cNvPicPr>
+            <a:picLocks noChangeAspect="1"/>
+          </p:cNvPicPr>
+          <p:nvPr/>
+        </p:nvPicPr>
+        <p:blipFill>
+          <a:blip r:embed="rId8"/>
+          <a:stretch>
+            <a:fillRect/>
+          </a:stretch>
+        </p:blipFill>
+        <p:spPr>
+          <a:xfrm>
+            <a:off x="22989027" y="20323059"/>
+            <a:ext cx="8507022" cy="4433532"/>
+          </a:xfrm>
+          <a:prstGeom prst="rect">
+            <a:avLst/>
+          </a:prstGeom>
+        </p:spPr>
+      </p:pic>
+      <p:pic>
+        <p:nvPicPr>
+          <p:cNvPr id="4105" name="Picture 4104">
+            <a:extLst>
+              <a:ext uri="{FF2B5EF4-FFF2-40B4-BE49-F238E27FC236}">
+                <a16:creationId xmlns:a16="http://schemas.microsoft.com/office/drawing/2014/main" id="{0DC3B3CF-D257-23EA-B1A7-A61773876D1A}"/>
+              </a:ext>
+            </a:extLst>
+          </p:cNvPr>
+          <p:cNvPicPr>
+            <a:picLocks noChangeAspect="1"/>
+          </p:cNvPicPr>
+          <p:nvPr/>
+        </p:nvPicPr>
+        <p:blipFill>
+          <a:blip r:embed="rId9"/>
+          <a:stretch>
+            <a:fillRect/>
+          </a:stretch>
+        </p:blipFill>
+        <p:spPr>
+          <a:xfrm>
+            <a:off x="33656519" y="13834699"/>
+            <a:ext cx="9313292" cy="4566205"/>
+          </a:xfrm>
+          <a:prstGeom prst="rect">
+            <a:avLst/>
+          </a:prstGeom>
+        </p:spPr>
+      </p:pic>
+      <p:sp>
+        <p:nvSpPr>
+          <p:cNvPr id="4106" name="Text Placeholder 6">
+            <a:extLst>
+              <a:ext uri="{FF2B5EF4-FFF2-40B4-BE49-F238E27FC236}">
+                <a16:creationId xmlns:a16="http://schemas.microsoft.com/office/drawing/2014/main" id="{5EE93C39-D4B7-3D45-5E36-D3EB6767D705}"/>
+              </a:ext>
+            </a:extLst>
+          </p:cNvPr>
+          <p:cNvSpPr txBox="1">
+            <a:spLocks/>
+          </p:cNvSpPr>
+          <p:nvPr/>
+        </p:nvSpPr>
+        <p:spPr>
+          <a:xfrm>
+            <a:off x="33395743" y="5619610"/>
+            <a:ext cx="10048874" cy="1308028"/>
+          </a:xfrm>
+          <a:prstGeom prst="rect">
+            <a:avLst/>
+          </a:prstGeom>
+        </p:spPr>
+        <p:txBody>
+          <a:bodyPr wrap="square" lIns="228589" tIns="228589" rIns="228589" bIns="228589">
+            <a:spAutoFit/>
+          </a:bodyPr>
+          <a:lstStyle>
+            <a:lvl1pPr marL="0" indent="0" algn="l" defTabSz="4388900" rtl="0" eaLnBrk="1" latinLnBrk="0" hangingPunct="1">
+              <a:spcBef>
+                <a:spcPct val="20000"/>
+              </a:spcBef>
+              <a:buFont typeface="Arial" pitchFamily="34" charset="0"/>
+              <a:buNone/>
+              <a:defRPr sz="2500" kern="1200">
+                <a:solidFill>
+                  <a:schemeClr val="accent5">
+                    <a:lumMod val="50000"/>
+                  </a:schemeClr>
+                </a:solidFill>
+                <a:latin typeface="Times New Roman" pitchFamily="18" charset="0"/>
+                <a:ea typeface="+mn-ea"/>
+                <a:cs typeface="Times New Roman" pitchFamily="18" charset="0"/>
+              </a:defRPr>
+            </a:lvl1pPr>
+            <a:lvl2pPr marL="1485825" indent="-571471" algn="l" defTabSz="4388900" rtl="0" eaLnBrk="1" latinLnBrk="0" hangingPunct="1">
+              <a:spcBef>
+                <a:spcPct val="20000"/>
+              </a:spcBef>
+              <a:buFont typeface="Arial" pitchFamily="34" charset="0"/>
+              <a:buChar char="–"/>
+              <a:defRPr sz="2500" kern="1200">
+                <a:solidFill>
+                  <a:schemeClr val="tx1"/>
+                </a:solidFill>
+                <a:latin typeface="Trebuchet MS" pitchFamily="34" charset="0"/>
+                <a:ea typeface="+mn-ea"/>
+                <a:cs typeface="+mn-cs"/>
+              </a:defRPr>
+            </a:lvl2pPr>
+            <a:lvl3pPr marL="2057297" indent="-571471" algn="l" defTabSz="4388900" rtl="0" eaLnBrk="1" latinLnBrk="0" hangingPunct="1">
+              <a:spcBef>
+                <a:spcPct val="20000"/>
+              </a:spcBef>
+              <a:buFont typeface="Arial" pitchFamily="34" charset="0"/>
+              <a:buChar char="•"/>
+              <a:defRPr sz="2500" kern="1200">
+                <a:solidFill>
+                  <a:schemeClr val="tx1"/>
+                </a:solidFill>
+                <a:latin typeface="Trebuchet MS" pitchFamily="34" charset="0"/>
+                <a:ea typeface="+mn-ea"/>
+                <a:cs typeface="+mn-cs"/>
+              </a:defRPr>
+            </a:lvl3pPr>
+            <a:lvl4pPr marL="2685916" indent="-628619" algn="l" defTabSz="4388900" rtl="0" eaLnBrk="1" latinLnBrk="0" hangingPunct="1">
+              <a:spcBef>
+                <a:spcPct val="20000"/>
+              </a:spcBef>
+              <a:buFont typeface="Arial" pitchFamily="34" charset="0"/>
+              <a:buChar char="–"/>
+              <a:defRPr sz="2500" kern="1200">
+                <a:solidFill>
+                  <a:schemeClr val="tx1"/>
+                </a:solidFill>
+                <a:latin typeface="Trebuchet MS" pitchFamily="34" charset="0"/>
+                <a:ea typeface="+mn-ea"/>
+                <a:cs typeface="+mn-cs"/>
+              </a:defRPr>
+            </a:lvl4pPr>
+            <a:lvl5pPr marL="3143093" indent="-457177" algn="l" defTabSz="4388900" rtl="0" eaLnBrk="1" latinLnBrk="0" hangingPunct="1">
+              <a:spcBef>
+                <a:spcPct val="20000"/>
+              </a:spcBef>
+              <a:buFont typeface="Arial" pitchFamily="34" charset="0"/>
+              <a:buChar char="»"/>
+              <a:defRPr sz="2500" kern="1200">
+                <a:solidFill>
+                  <a:schemeClr val="tx1"/>
+                </a:solidFill>
+                <a:latin typeface="Trebuchet MS" pitchFamily="34" charset="0"/>
+                <a:ea typeface="+mn-ea"/>
+                <a:cs typeface="+mn-cs"/>
+              </a:defRPr>
+            </a:lvl5pPr>
+            <a:lvl6pPr marL="12069477" indent="-1097226" algn="l" defTabSz="4388900" rtl="0" eaLnBrk="1" latinLnBrk="0" hangingPunct="1">
+              <a:spcBef>
+                <a:spcPct val="20000"/>
+              </a:spcBef>
+              <a:buFont typeface="Arial" pitchFamily="34" charset="0"/>
+              <a:buChar char="•"/>
+              <a:defRPr sz="9600" kern="1200">
+                <a:solidFill>
+                  <a:schemeClr val="tx1"/>
+                </a:solidFill>
+                <a:latin typeface="+mn-lt"/>
+                <a:ea typeface="+mn-ea"/>
+                <a:cs typeface="+mn-cs"/>
+              </a:defRPr>
+            </a:lvl6pPr>
+            <a:lvl7pPr marL="14263926" indent="-1097226" algn="l" defTabSz="4388900" rtl="0" eaLnBrk="1" latinLnBrk="0" hangingPunct="1">
+              <a:spcBef>
+                <a:spcPct val="20000"/>
+              </a:spcBef>
+              <a:buFont typeface="Arial" pitchFamily="34" charset="0"/>
+              <a:buChar char="•"/>
+              <a:defRPr sz="9600" kern="1200">
+                <a:solidFill>
+                  <a:schemeClr val="tx1"/>
+                </a:solidFill>
+                <a:latin typeface="+mn-lt"/>
+                <a:ea typeface="+mn-ea"/>
+                <a:cs typeface="+mn-cs"/>
+              </a:defRPr>
+            </a:lvl7pPr>
+            <a:lvl8pPr marL="16458377" indent="-1097226" algn="l" defTabSz="4388900" rtl="0" eaLnBrk="1" latinLnBrk="0" hangingPunct="1">
+              <a:spcBef>
+                <a:spcPct val="20000"/>
+              </a:spcBef>
+              <a:buFont typeface="Arial" pitchFamily="34" charset="0"/>
+              <a:buChar char="•"/>
+              <a:defRPr sz="9600" kern="1200">
+                <a:solidFill>
+                  <a:schemeClr val="tx1"/>
+                </a:solidFill>
+                <a:latin typeface="+mn-lt"/>
+                <a:ea typeface="+mn-ea"/>
+                <a:cs typeface="+mn-cs"/>
+              </a:defRPr>
+            </a:lvl8pPr>
+            <a:lvl9pPr marL="18652827" indent="-1097226" algn="l" defTabSz="4388900" rtl="0" eaLnBrk="1" latinLnBrk="0" hangingPunct="1">
+              <a:spcBef>
+                <a:spcPct val="20000"/>
+              </a:spcBef>
+              <a:buFont typeface="Arial" pitchFamily="34" charset="0"/>
+              <a:buChar char="•"/>
+              <a:defRPr sz="9600" kern="1200">
+                <a:solidFill>
+                  <a:schemeClr val="tx1"/>
+                </a:solidFill>
+                <a:latin typeface="+mn-lt"/>
+                <a:ea typeface="+mn-ea"/>
+                <a:cs typeface="+mn-cs"/>
+              </a:defRPr>
+            </a:lvl9pPr>
+          </a:lstStyle>
+          <a:p>
+            <a:r>
+              <a:rPr lang="en-US" i="1" u="sng" dirty="0">
+                <a:solidFill>
+                  <a:schemeClr val="tx2"/>
+                </a:solidFill>
+                <a:latin typeface="Arial" panose="020B0604020202020204" pitchFamily="34" charset="0"/>
+                <a:cs typeface="Arial" panose="020B0604020202020204" pitchFamily="34" charset="0"/>
+              </a:rPr>
+              <a:t>Model Accuracy — Actual vs Predicted Occupancy</a:t>
+            </a:r>
+          </a:p>
+          <a:p>
+            <a:endParaRPr lang="en-US" i="1" u="sng" dirty="0">
+              <a:solidFill>
+                <a:schemeClr val="tx2"/>
+              </a:solidFill>
+              <a:latin typeface="Arial" panose="020B0604020202020204" pitchFamily="34" charset="0"/>
+              <a:cs typeface="Arial" panose="020B0604020202020204" pitchFamily="34" charset="0"/>
+            </a:endParaRPr>
+          </a:p>
+        </p:txBody>
+      </p:sp>
+      <p:sp>
+        <p:nvSpPr>
+          <p:cNvPr id="4107" name="Text Placeholder 11">
+            <a:extLst>
+              <a:ext uri="{FF2B5EF4-FFF2-40B4-BE49-F238E27FC236}">
+                <a16:creationId xmlns:a16="http://schemas.microsoft.com/office/drawing/2014/main" id="{AECE974E-F71E-E5F4-5572-8595BC039CC1}"/>
+              </a:ext>
+            </a:extLst>
+          </p:cNvPr>
+          <p:cNvSpPr txBox="1">
+            <a:spLocks/>
+          </p:cNvSpPr>
+          <p:nvPr/>
+        </p:nvSpPr>
+        <p:spPr>
+          <a:xfrm>
+            <a:off x="33427274" y="6246459"/>
+            <a:ext cx="10052050" cy="3924129"/>
+          </a:xfrm>
+          <a:prstGeom prst="rect">
+            <a:avLst/>
+          </a:prstGeom>
+        </p:spPr>
+        <p:txBody>
+          <a:bodyPr wrap="square" lIns="228589" tIns="228589" rIns="228589" bIns="228589">
+            <a:spAutoFit/>
+          </a:bodyPr>
+          <a:lstStyle>
+            <a:lvl1pPr marL="0" indent="0" algn="l" defTabSz="4388900" rtl="0" eaLnBrk="1" latinLnBrk="0" hangingPunct="1">
+              <a:spcBef>
+                <a:spcPct val="20000"/>
+              </a:spcBef>
+              <a:buFont typeface="Arial" pitchFamily="34" charset="0"/>
+              <a:buNone/>
+              <a:defRPr sz="2500" kern="1200">
+                <a:solidFill>
+                  <a:schemeClr val="accent5">
+                    <a:lumMod val="50000"/>
+                  </a:schemeClr>
+                </a:solidFill>
+                <a:latin typeface="Times New Roman" pitchFamily="18" charset="0"/>
+                <a:ea typeface="+mn-ea"/>
+                <a:cs typeface="Times New Roman" pitchFamily="18" charset="0"/>
+              </a:defRPr>
+            </a:lvl1pPr>
+            <a:lvl2pPr marL="1485825" indent="-571471" algn="l" defTabSz="4388900" rtl="0" eaLnBrk="1" latinLnBrk="0" hangingPunct="1">
+              <a:spcBef>
+                <a:spcPct val="20000"/>
+              </a:spcBef>
+              <a:buFont typeface="Arial" pitchFamily="34" charset="0"/>
+              <a:buChar char="–"/>
+              <a:defRPr sz="2500" kern="1200">
+                <a:solidFill>
+                  <a:schemeClr val="tx1"/>
+                </a:solidFill>
+                <a:latin typeface="Trebuchet MS" pitchFamily="34" charset="0"/>
+                <a:ea typeface="+mn-ea"/>
+                <a:cs typeface="+mn-cs"/>
+              </a:defRPr>
+            </a:lvl2pPr>
+            <a:lvl3pPr marL="2057297" indent="-571471" algn="l" defTabSz="4388900" rtl="0" eaLnBrk="1" latinLnBrk="0" hangingPunct="1">
+              <a:spcBef>
+                <a:spcPct val="20000"/>
+              </a:spcBef>
+              <a:buFont typeface="Arial" pitchFamily="34" charset="0"/>
+              <a:buChar char="•"/>
+              <a:defRPr sz="2500" kern="1200">
+                <a:solidFill>
+                  <a:schemeClr val="tx1"/>
+                </a:solidFill>
+                <a:latin typeface="Trebuchet MS" pitchFamily="34" charset="0"/>
+                <a:ea typeface="+mn-ea"/>
+                <a:cs typeface="+mn-cs"/>
+              </a:defRPr>
+            </a:lvl3pPr>
+            <a:lvl4pPr marL="2685916" indent="-628619" algn="l" defTabSz="4388900" rtl="0" eaLnBrk="1" latinLnBrk="0" hangingPunct="1">
+              <a:spcBef>
+                <a:spcPct val="20000"/>
+              </a:spcBef>
+              <a:buFont typeface="Arial" pitchFamily="34" charset="0"/>
+              <a:buChar char="–"/>
+              <a:defRPr sz="2500" kern="1200">
+                <a:solidFill>
+                  <a:schemeClr val="tx1"/>
+                </a:solidFill>
+                <a:latin typeface="Trebuchet MS" pitchFamily="34" charset="0"/>
+                <a:ea typeface="+mn-ea"/>
+                <a:cs typeface="+mn-cs"/>
+              </a:defRPr>
+            </a:lvl4pPr>
+            <a:lvl5pPr marL="3143093" indent="-457177" algn="l" defTabSz="4388900" rtl="0" eaLnBrk="1" latinLnBrk="0" hangingPunct="1">
+              <a:spcBef>
+                <a:spcPct val="20000"/>
+              </a:spcBef>
+              <a:buFont typeface="Arial" pitchFamily="34" charset="0"/>
+              <a:buChar char="»"/>
+              <a:defRPr sz="2500" kern="1200">
+                <a:solidFill>
+                  <a:schemeClr val="tx1"/>
+                </a:solidFill>
+                <a:latin typeface="Trebuchet MS" pitchFamily="34" charset="0"/>
+                <a:ea typeface="+mn-ea"/>
+                <a:cs typeface="+mn-cs"/>
+              </a:defRPr>
+            </a:lvl5pPr>
+            <a:lvl6pPr marL="12069477" indent="-1097226" algn="l" defTabSz="4388900" rtl="0" eaLnBrk="1" latinLnBrk="0" hangingPunct="1">
+              <a:spcBef>
+                <a:spcPct val="20000"/>
+              </a:spcBef>
+              <a:buFont typeface="Arial" pitchFamily="34" charset="0"/>
+              <a:buChar char="•"/>
+              <a:defRPr sz="9600" kern="1200">
+                <a:solidFill>
+                  <a:schemeClr val="tx1"/>
+                </a:solidFill>
+                <a:latin typeface="+mn-lt"/>
+                <a:ea typeface="+mn-ea"/>
+                <a:cs typeface="+mn-cs"/>
+              </a:defRPr>
+            </a:lvl6pPr>
+            <a:lvl7pPr marL="14263926" indent="-1097226" algn="l" defTabSz="4388900" rtl="0" eaLnBrk="1" latinLnBrk="0" hangingPunct="1">
+              <a:spcBef>
+                <a:spcPct val="20000"/>
+              </a:spcBef>
+              <a:buFont typeface="Arial" pitchFamily="34" charset="0"/>
+              <a:buChar char="•"/>
+              <a:defRPr sz="9600" kern="1200">
+                <a:solidFill>
+                  <a:schemeClr val="tx1"/>
+                </a:solidFill>
+                <a:latin typeface="+mn-lt"/>
+                <a:ea typeface="+mn-ea"/>
+                <a:cs typeface="+mn-cs"/>
+              </a:defRPr>
+            </a:lvl7pPr>
+            <a:lvl8pPr marL="16458377" indent="-1097226" algn="l" defTabSz="4388900" rtl="0" eaLnBrk="1" latinLnBrk="0" hangingPunct="1">
+              <a:spcBef>
+                <a:spcPct val="20000"/>
+              </a:spcBef>
+              <a:buFont typeface="Arial" pitchFamily="34" charset="0"/>
+              <a:buChar char="•"/>
+              <a:defRPr sz="9600" kern="1200">
+                <a:solidFill>
+                  <a:schemeClr val="tx1"/>
+                </a:solidFill>
+                <a:latin typeface="+mn-lt"/>
+                <a:ea typeface="+mn-ea"/>
+                <a:cs typeface="+mn-cs"/>
+              </a:defRPr>
+            </a:lvl8pPr>
+            <a:lvl9pPr marL="18652827" indent="-1097226" algn="l" defTabSz="4388900" rtl="0" eaLnBrk="1" latinLnBrk="0" hangingPunct="1">
+              <a:spcBef>
+                <a:spcPct val="20000"/>
+              </a:spcBef>
+              <a:buFont typeface="Arial" pitchFamily="34" charset="0"/>
+              <a:buChar char="•"/>
+              <a:defRPr sz="9600" kern="1200">
+                <a:solidFill>
+                  <a:schemeClr val="tx1"/>
+                </a:solidFill>
+                <a:latin typeface="+mn-lt"/>
+                <a:ea typeface="+mn-ea"/>
+                <a:cs typeface="+mn-cs"/>
+              </a:defRPr>
+            </a:lvl9pPr>
+          </a:lstStyle>
+          <a:p>
+            <a:r>
+              <a:rPr lang="en-US" dirty="0">
+                <a:solidFill>
+                  <a:schemeClr val="tx1"/>
+                </a:solidFill>
+                <a:latin typeface="Arial" panose="020B0604020202020204" pitchFamily="34" charset="0"/>
+                <a:cs typeface="Arial" panose="020B0604020202020204" pitchFamily="34" charset="0"/>
+              </a:rPr>
+              <a:t>The scatter plot below compares the model's predicted guest numbers against the actual recorded occupancy across the 147-day test period. Each dot represents one day. A perfect model would place every dot exactly on the diagonal line. The tight clustering of points around the diagonal confirms the model learned genuine patterns rather than random noise. The slight spread at lower occupancy values indicates the model is marginally less precise on quieter nights, which has minimal impact on staffing decisions as these are the easiest periods to manage</a:t>
+            </a:r>
+          </a:p>
+        </p:txBody>
+      </p:sp>
+      <p:sp>
+        <p:nvSpPr>
+          <p:cNvPr id="4108" name="Text Placeholder 6">
+            <a:extLst>
+              <a:ext uri="{FF2B5EF4-FFF2-40B4-BE49-F238E27FC236}">
+                <a16:creationId xmlns:a16="http://schemas.microsoft.com/office/drawing/2014/main" id="{C836E6B4-8276-34A9-F8FE-C29ADDB1E038}"/>
+              </a:ext>
+            </a:extLst>
+          </p:cNvPr>
+          <p:cNvSpPr txBox="1">
+            <a:spLocks/>
+          </p:cNvSpPr>
+          <p:nvPr/>
+        </p:nvSpPr>
+        <p:spPr>
+          <a:xfrm>
+            <a:off x="22455719" y="25017739"/>
+            <a:ext cx="10048874" cy="846363"/>
+          </a:xfrm>
+          <a:prstGeom prst="rect">
+            <a:avLst/>
+          </a:prstGeom>
+        </p:spPr>
+        <p:txBody>
+          <a:bodyPr wrap="square" lIns="228589" tIns="228589" rIns="228589" bIns="228589">
+            <a:spAutoFit/>
+          </a:bodyPr>
+          <a:lstStyle>
+            <a:lvl1pPr marL="0" indent="0" algn="l" defTabSz="4388900" rtl="0" eaLnBrk="1" latinLnBrk="0" hangingPunct="1">
+              <a:spcBef>
+                <a:spcPct val="20000"/>
+              </a:spcBef>
+              <a:buFont typeface="Arial" pitchFamily="34" charset="0"/>
+              <a:buNone/>
+              <a:defRPr sz="2500" kern="1200">
+                <a:solidFill>
+                  <a:schemeClr val="accent5">
+                    <a:lumMod val="50000"/>
+                  </a:schemeClr>
+                </a:solidFill>
+                <a:latin typeface="Times New Roman" pitchFamily="18" charset="0"/>
+                <a:ea typeface="+mn-ea"/>
+                <a:cs typeface="Times New Roman" pitchFamily="18" charset="0"/>
+              </a:defRPr>
+            </a:lvl1pPr>
+            <a:lvl2pPr marL="1485825" indent="-571471" algn="l" defTabSz="4388900" rtl="0" eaLnBrk="1" latinLnBrk="0" hangingPunct="1">
+              <a:spcBef>
+                <a:spcPct val="20000"/>
+              </a:spcBef>
+              <a:buFont typeface="Arial" pitchFamily="34" charset="0"/>
+              <a:buChar char="–"/>
+              <a:defRPr sz="2500" kern="1200">
+                <a:solidFill>
+                  <a:schemeClr val="tx1"/>
+                </a:solidFill>
+                <a:latin typeface="Trebuchet MS" pitchFamily="34" charset="0"/>
+                <a:ea typeface="+mn-ea"/>
+                <a:cs typeface="+mn-cs"/>
+              </a:defRPr>
+            </a:lvl2pPr>
+            <a:lvl3pPr marL="2057297" indent="-571471" algn="l" defTabSz="4388900" rtl="0" eaLnBrk="1" latinLnBrk="0" hangingPunct="1">
+              <a:spcBef>
+                <a:spcPct val="20000"/>
+              </a:spcBef>
+              <a:buFont typeface="Arial" pitchFamily="34" charset="0"/>
+              <a:buChar char="•"/>
+              <a:defRPr sz="2500" kern="1200">
+                <a:solidFill>
+                  <a:schemeClr val="tx1"/>
+                </a:solidFill>
+                <a:latin typeface="Trebuchet MS" pitchFamily="34" charset="0"/>
+                <a:ea typeface="+mn-ea"/>
+                <a:cs typeface="+mn-cs"/>
+              </a:defRPr>
+            </a:lvl3pPr>
+            <a:lvl4pPr marL="2685916" indent="-628619" algn="l" defTabSz="4388900" rtl="0" eaLnBrk="1" latinLnBrk="0" hangingPunct="1">
+              <a:spcBef>
+                <a:spcPct val="20000"/>
+              </a:spcBef>
+              <a:buFont typeface="Arial" pitchFamily="34" charset="0"/>
+              <a:buChar char="–"/>
+              <a:defRPr sz="2500" kern="1200">
+                <a:solidFill>
+                  <a:schemeClr val="tx1"/>
+                </a:solidFill>
+                <a:latin typeface="Trebuchet MS" pitchFamily="34" charset="0"/>
+                <a:ea typeface="+mn-ea"/>
+                <a:cs typeface="+mn-cs"/>
+              </a:defRPr>
+            </a:lvl4pPr>
+            <a:lvl5pPr marL="3143093" indent="-457177" algn="l" defTabSz="4388900" rtl="0" eaLnBrk="1" latinLnBrk="0" hangingPunct="1">
+              <a:spcBef>
+                <a:spcPct val="20000"/>
+              </a:spcBef>
+              <a:buFont typeface="Arial" pitchFamily="34" charset="0"/>
+              <a:buChar char="»"/>
+              <a:defRPr sz="2500" kern="1200">
+                <a:solidFill>
+                  <a:schemeClr val="tx1"/>
+                </a:solidFill>
+                <a:latin typeface="Trebuchet MS" pitchFamily="34" charset="0"/>
+                <a:ea typeface="+mn-ea"/>
+                <a:cs typeface="+mn-cs"/>
+              </a:defRPr>
+            </a:lvl5pPr>
+            <a:lvl6pPr marL="12069477" indent="-1097226" algn="l" defTabSz="4388900" rtl="0" eaLnBrk="1" latinLnBrk="0" hangingPunct="1">
+              <a:spcBef>
+                <a:spcPct val="20000"/>
+              </a:spcBef>
+              <a:buFont typeface="Arial" pitchFamily="34" charset="0"/>
+              <a:buChar char="•"/>
+              <a:defRPr sz="9600" kern="1200">
+                <a:solidFill>
+                  <a:schemeClr val="tx1"/>
+                </a:solidFill>
+                <a:latin typeface="+mn-lt"/>
+                <a:ea typeface="+mn-ea"/>
+                <a:cs typeface="+mn-cs"/>
+              </a:defRPr>
+            </a:lvl6pPr>
+            <a:lvl7pPr marL="14263926" indent="-1097226" algn="l" defTabSz="4388900" rtl="0" eaLnBrk="1" latinLnBrk="0" hangingPunct="1">
+              <a:spcBef>
+                <a:spcPct val="20000"/>
+              </a:spcBef>
+              <a:buFont typeface="Arial" pitchFamily="34" charset="0"/>
+              <a:buChar char="•"/>
+              <a:defRPr sz="9600" kern="1200">
+                <a:solidFill>
+                  <a:schemeClr val="tx1"/>
+                </a:solidFill>
+                <a:latin typeface="+mn-lt"/>
+                <a:ea typeface="+mn-ea"/>
+                <a:cs typeface="+mn-cs"/>
+              </a:defRPr>
+            </a:lvl7pPr>
+            <a:lvl8pPr marL="16458377" indent="-1097226" algn="l" defTabSz="4388900" rtl="0" eaLnBrk="1" latinLnBrk="0" hangingPunct="1">
+              <a:spcBef>
+                <a:spcPct val="20000"/>
+              </a:spcBef>
+              <a:buFont typeface="Arial" pitchFamily="34" charset="0"/>
+              <a:buChar char="•"/>
+              <a:defRPr sz="9600" kern="1200">
+                <a:solidFill>
+                  <a:schemeClr val="tx1"/>
+                </a:solidFill>
+                <a:latin typeface="+mn-lt"/>
+                <a:ea typeface="+mn-ea"/>
+                <a:cs typeface="+mn-cs"/>
+              </a:defRPr>
+            </a:lvl8pPr>
+            <a:lvl9pPr marL="18652827" indent="-1097226" algn="l" defTabSz="4388900" rtl="0" eaLnBrk="1" latinLnBrk="0" hangingPunct="1">
+              <a:spcBef>
+                <a:spcPct val="20000"/>
+              </a:spcBef>
+              <a:buFont typeface="Arial" pitchFamily="34" charset="0"/>
+              <a:buChar char="•"/>
+              <a:defRPr sz="9600" kern="1200">
+                <a:solidFill>
+                  <a:schemeClr val="tx1"/>
+                </a:solidFill>
+                <a:latin typeface="+mn-lt"/>
+                <a:ea typeface="+mn-ea"/>
+                <a:cs typeface="+mn-cs"/>
+              </a:defRPr>
+            </a:lvl9pPr>
+          </a:lstStyle>
+          <a:p>
+            <a:r>
+              <a:rPr lang="en-US" i="1" u="sng" dirty="0">
+                <a:latin typeface="Arial" panose="020B0604020202020204" pitchFamily="34" charset="0"/>
+                <a:cs typeface="Arial" panose="020B0604020202020204" pitchFamily="34" charset="0"/>
+              </a:rPr>
+              <a:t>Feature Importance</a:t>
+            </a:r>
+          </a:p>
+        </p:txBody>
+      </p:sp>
+      <p:sp>
+        <p:nvSpPr>
+          <p:cNvPr id="4109" name="Content Placeholder 2">
+            <a:extLst>
+              <a:ext uri="{FF2B5EF4-FFF2-40B4-BE49-F238E27FC236}">
+                <a16:creationId xmlns:a16="http://schemas.microsoft.com/office/drawing/2014/main" id="{B81B1A0F-25E9-6928-FCCE-A9A259874501}"/>
+              </a:ext>
+            </a:extLst>
+          </p:cNvPr>
+          <p:cNvSpPr txBox="1">
+            <a:spLocks/>
+          </p:cNvSpPr>
+          <p:nvPr/>
+        </p:nvSpPr>
+        <p:spPr>
+          <a:xfrm>
+            <a:off x="22631027" y="25739867"/>
+            <a:ext cx="9428190" cy="3739855"/>
+          </a:xfrm>
+          <a:prstGeom prst="rect">
+            <a:avLst/>
+          </a:prstGeom>
+        </p:spPr>
+        <p:txBody>
+          <a:bodyPr>
+            <a:noAutofit/>
+          </a:bodyPr>
+          <a:lstStyle>
+            <a:lvl1pPr marL="1645838" indent="-1645838" algn="l" defTabSz="4388900" rtl="0" eaLnBrk="1" latinLnBrk="0" hangingPunct="1">
+              <a:spcBef>
+                <a:spcPct val="20000"/>
+              </a:spcBef>
+              <a:buFont typeface="Arial" pitchFamily="34" charset="0"/>
+              <a:buChar char="•"/>
+              <a:defRPr sz="15400" kern="1200">
+                <a:solidFill>
+                  <a:schemeClr val="tx1"/>
+                </a:solidFill>
+                <a:latin typeface="+mn-lt"/>
+                <a:ea typeface="+mn-ea"/>
+                <a:cs typeface="+mn-cs"/>
+              </a:defRPr>
+            </a:lvl1pPr>
+            <a:lvl2pPr marL="3565982" indent="-1371531" algn="l" defTabSz="4388900" rtl="0" eaLnBrk="1" latinLnBrk="0" hangingPunct="1">
+              <a:spcBef>
+                <a:spcPct val="20000"/>
+              </a:spcBef>
+              <a:buFont typeface="Arial" pitchFamily="34" charset="0"/>
+              <a:buChar char="–"/>
+              <a:defRPr sz="13500" kern="1200">
+                <a:solidFill>
+                  <a:schemeClr val="tx1"/>
+                </a:solidFill>
+                <a:latin typeface="+mn-lt"/>
+                <a:ea typeface="+mn-ea"/>
+                <a:cs typeface="+mn-cs"/>
+              </a:defRPr>
+            </a:lvl2pPr>
+            <a:lvl3pPr marL="5486126" indent="-1097226" algn="l" defTabSz="4388900" rtl="0" eaLnBrk="1" latinLnBrk="0" hangingPunct="1">
+              <a:spcBef>
+                <a:spcPct val="20000"/>
+              </a:spcBef>
+              <a:buFont typeface="Arial" pitchFamily="34" charset="0"/>
+              <a:buChar char="•"/>
+              <a:defRPr sz="11600" kern="1200">
+                <a:solidFill>
+                  <a:schemeClr val="tx1"/>
+                </a:solidFill>
+                <a:latin typeface="+mn-lt"/>
+                <a:ea typeface="+mn-ea"/>
+                <a:cs typeface="+mn-cs"/>
+              </a:defRPr>
+            </a:lvl3pPr>
+            <a:lvl4pPr marL="7680577" indent="-1097226" algn="l" defTabSz="4388900" rtl="0" eaLnBrk="1" latinLnBrk="0" hangingPunct="1">
+              <a:spcBef>
+                <a:spcPct val="20000"/>
+              </a:spcBef>
+              <a:buFont typeface="Arial" pitchFamily="34" charset="0"/>
+              <a:buChar char="–"/>
+              <a:defRPr sz="9600" kern="1200">
+                <a:solidFill>
+                  <a:schemeClr val="tx1"/>
+                </a:solidFill>
+                <a:latin typeface="+mn-lt"/>
+                <a:ea typeface="+mn-ea"/>
+                <a:cs typeface="+mn-cs"/>
+              </a:defRPr>
+            </a:lvl4pPr>
+            <a:lvl5pPr marL="9875026" indent="-1097226" algn="l" defTabSz="4388900" rtl="0" eaLnBrk="1" latinLnBrk="0" hangingPunct="1">
+              <a:spcBef>
+                <a:spcPct val="20000"/>
+              </a:spcBef>
+              <a:buFont typeface="Arial" pitchFamily="34" charset="0"/>
+              <a:buChar char="»"/>
+              <a:defRPr sz="9600" kern="1200">
+                <a:solidFill>
+                  <a:schemeClr val="tx1"/>
+                </a:solidFill>
+                <a:latin typeface="+mn-lt"/>
+                <a:ea typeface="+mn-ea"/>
+                <a:cs typeface="+mn-cs"/>
+              </a:defRPr>
+            </a:lvl5pPr>
+            <a:lvl6pPr marL="12069477" indent="-1097226" algn="l" defTabSz="4388900" rtl="0" eaLnBrk="1" latinLnBrk="0" hangingPunct="1">
+              <a:spcBef>
+                <a:spcPct val="20000"/>
+              </a:spcBef>
+              <a:buFont typeface="Arial" pitchFamily="34" charset="0"/>
+              <a:buChar char="•"/>
+              <a:defRPr sz="9600" kern="1200">
+                <a:solidFill>
+                  <a:schemeClr val="tx1"/>
+                </a:solidFill>
+                <a:latin typeface="+mn-lt"/>
+                <a:ea typeface="+mn-ea"/>
+                <a:cs typeface="+mn-cs"/>
+              </a:defRPr>
+            </a:lvl6pPr>
+            <a:lvl7pPr marL="14263926" indent="-1097226" algn="l" defTabSz="4388900" rtl="0" eaLnBrk="1" latinLnBrk="0" hangingPunct="1">
+              <a:spcBef>
+                <a:spcPct val="20000"/>
+              </a:spcBef>
+              <a:buFont typeface="Arial" pitchFamily="34" charset="0"/>
+              <a:buChar char="•"/>
+              <a:defRPr sz="9600" kern="1200">
+                <a:solidFill>
+                  <a:schemeClr val="tx1"/>
+                </a:solidFill>
+                <a:latin typeface="+mn-lt"/>
+                <a:ea typeface="+mn-ea"/>
+                <a:cs typeface="+mn-cs"/>
+              </a:defRPr>
+            </a:lvl7pPr>
+            <a:lvl8pPr marL="16458377" indent="-1097226" algn="l" defTabSz="4388900" rtl="0" eaLnBrk="1" latinLnBrk="0" hangingPunct="1">
+              <a:spcBef>
+                <a:spcPct val="20000"/>
+              </a:spcBef>
+              <a:buFont typeface="Arial" pitchFamily="34" charset="0"/>
+              <a:buChar char="•"/>
+              <a:defRPr sz="9600" kern="1200">
+                <a:solidFill>
+                  <a:schemeClr val="tx1"/>
+                </a:solidFill>
+                <a:latin typeface="+mn-lt"/>
+                <a:ea typeface="+mn-ea"/>
+                <a:cs typeface="+mn-cs"/>
+              </a:defRPr>
+            </a:lvl8pPr>
+            <a:lvl9pPr marL="18652827" indent="-1097226" algn="l" defTabSz="4388900" rtl="0" eaLnBrk="1" latinLnBrk="0" hangingPunct="1">
+              <a:spcBef>
+                <a:spcPct val="20000"/>
+              </a:spcBef>
+              <a:buFont typeface="Arial" pitchFamily="34" charset="0"/>
+              <a:buChar char="•"/>
+              <a:defRPr sz="9600" kern="1200">
+                <a:solidFill>
+                  <a:schemeClr val="tx1"/>
+                </a:solidFill>
+                <a:latin typeface="+mn-lt"/>
+                <a:ea typeface="+mn-ea"/>
+                <a:cs typeface="+mn-cs"/>
+              </a:defRPr>
+            </a:lvl9pPr>
+          </a:lstStyle>
+          <a:p>
+            <a:pPr marL="0" indent="0">
+              <a:buNone/>
+            </a:pPr>
+            <a:r>
+              <a:rPr lang="en-US" sz="2500" dirty="0"/>
+              <a:t>The scatter plot below compares the model's predicted guest numbers against the actual recorded occupancy across the test period. Each dot represents one day. A perfect model would place every dot exactly on the diagonal line. The tight clustering of points around the diagonal confirms the model learned genuine patterns rather than random noise</a:t>
+            </a:r>
+            <a:endParaRPr lang="en-IE" sz="2500" dirty="0"/>
+          </a:p>
+        </p:txBody>
+      </p:sp>
+      <p:pic>
+        <p:nvPicPr>
+          <p:cNvPr id="4110" name="Picture 4109">
+            <a:extLst>
+              <a:ext uri="{FF2B5EF4-FFF2-40B4-BE49-F238E27FC236}">
+                <a16:creationId xmlns:a16="http://schemas.microsoft.com/office/drawing/2014/main" id="{30FEB3F4-83BF-7EA1-0BDB-E98AB862EDD0}"/>
+              </a:ext>
+            </a:extLst>
+          </p:cNvPr>
+          <p:cNvPicPr>
+            <a:picLocks noChangeAspect="1"/>
+          </p:cNvPicPr>
+          <p:nvPr/>
+        </p:nvPicPr>
+        <p:blipFill>
+          <a:blip r:embed="rId10"/>
+          <a:stretch>
+            <a:fillRect/>
+          </a:stretch>
+        </p:blipFill>
+        <p:spPr>
+          <a:xfrm>
+            <a:off x="23554705" y="27867848"/>
+            <a:ext cx="7032775" cy="4258307"/>
           </a:xfrm>
           <a:prstGeom prst="rect">
             <a:avLst/>

</xml_diff>